<commit_message>
Final Settlement Query Update
</commit_message>
<xml_diff>
--- a/APLOS/POPResources/Templates/QRIDCardHindi.pptx
+++ b/APLOS/POPResources/Templates/QRIDCardHindi.pptx
@@ -5,13 +5,14 @@
     <p:sldMasterId id="2147483648" r:id="rId1"/>
   </p:sldMasterIdLst>
   <p:notesMasterIdLst>
-    <p:notesMasterId r:id="rId3"/>
+    <p:notesMasterId r:id="rId4"/>
   </p:notesMasterIdLst>
   <p:handoutMasterIdLst>
-    <p:handoutMasterId r:id="rId4"/>
+    <p:handoutMasterId r:id="rId5"/>
   </p:handoutMasterIdLst>
   <p:sldIdLst>
     <p:sldId id="257" r:id="rId2"/>
+    <p:sldId id="256" r:id="rId3"/>
   </p:sldIdLst>
   <p:sldSz cx="1947863" cy="3090863"/>
   <p:notesSz cx="7104063" cy="10234613"/>
@@ -214,7 +215,7 @@
           <a:p>
             <a:fld id="{7B7E7892-5A32-4575-94C1-DE4A6525AA41}" type="datetimeFigureOut">
               <a:rPr lang="en-US" smtClean="0"/>
-              <a:t>9/6/2021</a:t>
+              <a:t>8/25/2021</a:t>
             </a:fld>
             <a:endParaRPr lang="en-US"/>
           </a:p>
@@ -392,7 +393,7 @@
           <a:p>
             <a:fld id="{2CB70909-C19F-4098-BABE-826759D4F724}" type="datetimeFigureOut">
               <a:rPr lang="en-US" smtClean="0"/>
-              <a:t>9/6/2021</a:t>
+              <a:t>8/25/2021</a:t>
             </a:fld>
             <a:endParaRPr lang="en-US"/>
           </a:p>
@@ -802,7 +803,7 @@
           <a:p>
             <a:fld id="{6595CB52-7A80-4EDE-BD89-15F3D80D2847}" type="datetime1">
               <a:rPr lang="en-US" smtClean="0"/>
-              <a:t>9/6/2021</a:t>
+              <a:t>8/25/2021</a:t>
             </a:fld>
             <a:endParaRPr lang="en-US" dirty="0"/>
           </a:p>
@@ -989,7 +990,7 @@
           <a:p>
             <a:fld id="{FCBAD589-A814-48D4-A41D-AEEBA8B062ED}" type="datetime1">
               <a:rPr lang="en-US" smtClean="0"/>
-              <a:t>9/6/2021</a:t>
+              <a:t>8/25/2021</a:t>
             </a:fld>
             <a:endParaRPr lang="en-US" dirty="0"/>
           </a:p>
@@ -1184,7 +1185,7 @@
           <a:p>
             <a:fld id="{9EE1E399-81D8-4F32-A773-79DD86C9D815}" type="datetime1">
               <a:rPr lang="en-US" smtClean="0"/>
-              <a:t>9/6/2021</a:t>
+              <a:t>8/25/2021</a:t>
             </a:fld>
             <a:endParaRPr lang="en-US" dirty="0"/>
           </a:p>
@@ -1371,7 +1372,7 @@
           <a:p>
             <a:fld id="{798256AB-61F5-4AE9-B2A9-B219460FA3D9}" type="datetime1">
               <a:rPr lang="en-US" smtClean="0"/>
-              <a:t>9/6/2021</a:t>
+              <a:t>8/25/2021</a:t>
             </a:fld>
             <a:endParaRPr lang="en-US" dirty="0"/>
           </a:p>
@@ -1633,7 +1634,7 @@
           <a:p>
             <a:fld id="{9232F403-2438-4303-9714-E49C6D0B1E28}" type="datetime1">
               <a:rPr lang="en-US" smtClean="0"/>
-              <a:t>9/6/2021</a:t>
+              <a:t>8/25/2021</a:t>
             </a:fld>
             <a:endParaRPr lang="en-US" dirty="0"/>
           </a:p>
@@ -1883,7 +1884,7 @@
           <a:p>
             <a:fld id="{5F4B6725-C72E-4A01-97E1-5898CAC1CF6F}" type="datetime1">
               <a:rPr lang="en-US" smtClean="0"/>
-              <a:t>9/6/2021</a:t>
+              <a:t>8/25/2021</a:t>
             </a:fld>
             <a:endParaRPr lang="en-US" dirty="0"/>
           </a:p>
@@ -2273,7 +2274,7 @@
           <a:p>
             <a:fld id="{2C272315-A371-4329-8393-D21113A0CC5B}" type="datetime1">
               <a:rPr lang="en-US" smtClean="0"/>
-              <a:t>9/6/2021</a:t>
+              <a:t>8/25/2021</a:t>
             </a:fld>
             <a:endParaRPr lang="en-US" dirty="0"/>
           </a:p>
@@ -2405,7 +2406,7 @@
           <a:p>
             <a:fld id="{E3501887-07F5-4895-9E1A-2035534BDEE9}" type="datetime1">
               <a:rPr lang="en-US" smtClean="0"/>
-              <a:t>9/6/2021</a:t>
+              <a:t>8/25/2021</a:t>
             </a:fld>
             <a:endParaRPr lang="en-US" dirty="0"/>
           </a:p>
@@ -2510,7 +2511,7 @@
           <a:p>
             <a:fld id="{F2A78092-FC37-4448-AF31-357D713EC2CE}" type="datetime1">
               <a:rPr lang="en-US" smtClean="0"/>
-              <a:t>9/6/2021</a:t>
+              <a:t>8/25/2021</a:t>
             </a:fld>
             <a:endParaRPr lang="en-US" dirty="0"/>
           </a:p>
@@ -2805,7 +2806,7 @@
           <a:p>
             <a:fld id="{68303B59-8064-4F92-9589-6397FBC99231}" type="datetime1">
               <a:rPr lang="en-US" smtClean="0"/>
-              <a:t>9/6/2021</a:t>
+              <a:t>8/25/2021</a:t>
             </a:fld>
             <a:endParaRPr lang="en-US" dirty="0"/>
           </a:p>
@@ -3078,7 +3079,7 @@
           <a:p>
             <a:fld id="{918ADC9D-7416-45ED-BDA5-6017A57A36C0}" type="datetime1">
               <a:rPr lang="en-US" smtClean="0"/>
-              <a:t>9/6/2021</a:t>
+              <a:t>8/25/2021</a:t>
             </a:fld>
             <a:endParaRPr lang="en-US" dirty="0"/>
           </a:p>
@@ -3308,7 +3309,7 @@
           <a:p>
             <a:fld id="{F0E8A625-E03B-4A49-8E37-41B5871683EF}" type="datetime1">
               <a:rPr lang="en-US" smtClean="0"/>
-              <a:t>9/6/2021</a:t>
+              <a:t>8/25/2021</a:t>
             </a:fld>
             <a:endParaRPr lang="en-US" dirty="0"/>
           </a:p>
@@ -3726,7 +3727,7 @@
         </p:blipFill>
         <p:spPr>
           <a:xfrm>
-            <a:off x="92510" y="612697"/>
+            <a:off x="556219" y="783151"/>
             <a:ext cx="664916" cy="752776"/>
           </a:xfrm>
           <a:prstGeom prst="roundRect">
@@ -3772,7 +3773,7 @@
         </p:nvSpPr>
         <p:spPr>
           <a:xfrm>
-            <a:off x="754531" y="1408691"/>
+            <a:off x="754531" y="1852823"/>
             <a:ext cx="1113425" cy="88873"/>
           </a:xfrm>
           <a:prstGeom prst="rect">
@@ -3893,7 +3894,7 @@
           </a:lstStyle>
           <a:p>
             <a:r>
-              <a:rPr lang="en-US" sz="800" b="1" dirty="0">
+              <a:rPr lang="en-US" sz="1000" b="1" dirty="0">
                 <a:latin typeface="Arial Narrow" panose="020B0606020202030204" pitchFamily="34" charset="0"/>
                 <a:cs typeface="Arial" panose="020B0604020202020204" pitchFamily="34" charset="0"/>
               </a:rPr>
@@ -3916,8 +3917,8 @@
         </p:nvSpPr>
         <p:spPr>
           <a:xfrm>
-            <a:off x="1234772" y="1128410"/>
-            <a:ext cx="614053" cy="112520"/>
+            <a:off x="754531" y="2067772"/>
+            <a:ext cx="932851" cy="88637"/>
           </a:xfrm>
           <a:prstGeom prst="rect">
             <a:avLst/>
@@ -4037,7 +4038,7 @@
           </a:lstStyle>
           <a:p>
             <a:r>
-              <a:rPr lang="en-US" sz="800" b="1" dirty="0">
+              <a:rPr lang="en-US" sz="1000" b="1" dirty="0">
                 <a:latin typeface="Arial Narrow" panose="020B0606020202030204" pitchFamily="34" charset="0"/>
                 <a:cs typeface="Arial" panose="020B0604020202020204" pitchFamily="34" charset="0"/>
               </a:rPr>
@@ -4048,10 +4049,10 @@
       </p:sp>
       <p:sp>
         <p:nvSpPr>
-          <p:cNvPr id="53" name="DOJ">
+          <p:cNvPr id="49" name="Department">
             <a:extLst>
               <a:ext uri="{FF2B5EF4-FFF2-40B4-BE49-F238E27FC236}">
-                <a16:creationId xmlns:a16="http://schemas.microsoft.com/office/drawing/2014/main" id="{5AD335E8-37F9-4F56-9A6F-0284430FCE43}"/>
+                <a16:creationId xmlns:a16="http://schemas.microsoft.com/office/drawing/2014/main" id="{FCDA8BA4-25C1-43A2-8D0F-75181B505AC7}"/>
               </a:ext>
             </a:extLst>
           </p:cNvPr>
@@ -4060,8 +4061,8 @@
         </p:nvSpPr>
         <p:spPr>
           <a:xfrm>
-            <a:off x="774873" y="1640516"/>
-            <a:ext cx="1054646" cy="120281"/>
+            <a:off x="746361" y="2282540"/>
+            <a:ext cx="1121595" cy="95343"/>
           </a:xfrm>
           <a:prstGeom prst="rect">
             <a:avLst/>
@@ -4181,21 +4182,21 @@
           </a:lstStyle>
           <a:p>
             <a:r>
-              <a:rPr lang="en-US" sz="800" b="1" dirty="0">
+              <a:rPr lang="en-US" sz="1000" b="1" dirty="0">
                 <a:latin typeface="Arial Narrow" panose="020B0606020202030204" pitchFamily="34" charset="0"/>
                 <a:cs typeface="Arial" panose="020B0604020202020204" pitchFamily="34" charset="0"/>
               </a:rPr>
-              <a:t>{DOJ}</a:t>
-            </a:r>
-          </a:p>
-        </p:txBody>
-      </p:sp>
-      <p:sp>
-        <p:nvSpPr>
-          <p:cNvPr id="55" name="DOJ">
+              <a:t>{Department}</a:t>
+            </a:r>
+          </a:p>
+        </p:txBody>
+      </p:sp>
+      <p:sp>
+        <p:nvSpPr>
+          <p:cNvPr id="53" name="DOJ">
             <a:extLst>
               <a:ext uri="{FF2B5EF4-FFF2-40B4-BE49-F238E27FC236}">
-                <a16:creationId xmlns:a16="http://schemas.microsoft.com/office/drawing/2014/main" id="{E88B1D44-6E86-483C-8414-2055C1FD6746}"/>
+                <a16:creationId xmlns:a16="http://schemas.microsoft.com/office/drawing/2014/main" id="{5AD335E8-37F9-4F56-9A6F-0284430FCE43}"/>
               </a:ext>
             </a:extLst>
           </p:cNvPr>
@@ -4204,8 +4205,8 @@
         </p:nvSpPr>
         <p:spPr>
           <a:xfrm>
-            <a:off x="1169115" y="2498728"/>
-            <a:ext cx="850583" cy="120281"/>
+            <a:off x="854008" y="2443873"/>
+            <a:ext cx="1054646" cy="120281"/>
           </a:xfrm>
           <a:prstGeom prst="rect">
             <a:avLst/>
@@ -4325,39 +4326,21 @@
           </a:lstStyle>
           <a:p>
             <a:r>
-              <a:rPr lang="hi-IN" sz="700" b="1" dirty="0">
+              <a:rPr lang="en-US" sz="1000" b="1" dirty="0">
                 <a:latin typeface="Arial Narrow" panose="020B0606020202030204" pitchFamily="34" charset="0"/>
                 <a:cs typeface="Arial" panose="020B0604020202020204" pitchFamily="34" charset="0"/>
               </a:rPr>
-              <a:t>अधिकृत</a:t>
-            </a:r>
-            <a:r>
-              <a:rPr lang="en-US" sz="700" b="1" dirty="0">
-                <a:latin typeface="Arial Narrow" panose="020B0606020202030204" pitchFamily="34" charset="0"/>
-                <a:cs typeface="Arial" panose="020B0604020202020204" pitchFamily="34" charset="0"/>
-              </a:rPr>
-              <a:t> </a:t>
-            </a:r>
-            <a:r>
-              <a:rPr lang="hi-IN" sz="700" b="1" dirty="0">
-                <a:latin typeface="Arial Narrow" panose="020B0606020202030204" pitchFamily="34" charset="0"/>
-                <a:cs typeface="Arial" panose="020B0604020202020204" pitchFamily="34" charset="0"/>
-              </a:rPr>
-              <a:t>हस्ताक्षर</a:t>
-            </a:r>
-            <a:endParaRPr lang="en-US" sz="700" b="1" dirty="0">
-              <a:latin typeface="Arial Narrow" panose="020B0606020202030204" pitchFamily="34" charset="0"/>
-              <a:cs typeface="Arial" panose="020B0604020202020204" pitchFamily="34" charset="0"/>
-            </a:endParaRPr>
-          </a:p>
-        </p:txBody>
-      </p:sp>
-      <p:sp>
-        <p:nvSpPr>
-          <p:cNvPr id="16" name="Name">
+              <a:t>{DOJ}</a:t>
+            </a:r>
+          </a:p>
+        </p:txBody>
+      </p:sp>
+      <p:sp>
+        <p:nvSpPr>
+          <p:cNvPr id="55" name="DOJ">
             <a:extLst>
               <a:ext uri="{FF2B5EF4-FFF2-40B4-BE49-F238E27FC236}">
-                <a16:creationId xmlns:a16="http://schemas.microsoft.com/office/drawing/2014/main" id="{C8F46744-08AA-4FDA-9050-49C076C77E40}"/>
+                <a16:creationId xmlns:a16="http://schemas.microsoft.com/office/drawing/2014/main" id="{E88B1D44-6E86-483C-8414-2055C1FD6746}"/>
               </a:ext>
             </a:extLst>
           </p:cNvPr>
@@ -4366,8 +4349,8 @@
         </p:nvSpPr>
         <p:spPr>
           <a:xfrm>
-            <a:off x="108003" y="1949305"/>
-            <a:ext cx="1113425" cy="94999"/>
+            <a:off x="1097280" y="2919059"/>
+            <a:ext cx="850583" cy="120281"/>
           </a:xfrm>
           <a:prstGeom prst="rect">
             <a:avLst/>
@@ -4486,7 +4469,169 @@
             </a:lvl9pPr>
           </a:lstStyle>
           <a:p>
-            <a:endParaRPr lang="en-US" sz="800" b="1" dirty="0">
+            <a:r>
+              <a:rPr lang="hi-IN" sz="800" dirty="0">
+                <a:latin typeface="Arial Narrow" panose="020B0606020202030204" pitchFamily="34" charset="0"/>
+                <a:cs typeface="Arial" panose="020B0604020202020204" pitchFamily="34" charset="0"/>
+              </a:rPr>
+              <a:t>अधिकृत</a:t>
+            </a:r>
+            <a:r>
+              <a:rPr lang="en-US" sz="800" dirty="0">
+                <a:latin typeface="Arial Narrow" panose="020B0606020202030204" pitchFamily="34" charset="0"/>
+                <a:cs typeface="Arial" panose="020B0604020202020204" pitchFamily="34" charset="0"/>
+              </a:rPr>
+              <a:t> </a:t>
+            </a:r>
+            <a:r>
+              <a:rPr lang="hi-IN" sz="800" dirty="0">
+                <a:latin typeface="Arial Narrow" panose="020B0606020202030204" pitchFamily="34" charset="0"/>
+                <a:cs typeface="Arial" panose="020B0604020202020204" pitchFamily="34" charset="0"/>
+              </a:rPr>
+              <a:t>हस्ताक्षर</a:t>
+            </a:r>
+            <a:endParaRPr lang="en-US" sz="800" dirty="0">
+              <a:latin typeface="Arial Narrow" panose="020B0606020202030204" pitchFamily="34" charset="0"/>
+              <a:cs typeface="Arial" panose="020B0604020202020204" pitchFamily="34" charset="0"/>
+            </a:endParaRPr>
+          </a:p>
+        </p:txBody>
+      </p:sp>
+      <p:sp>
+        <p:nvSpPr>
+          <p:cNvPr id="16" name="Name">
+            <a:extLst>
+              <a:ext uri="{FF2B5EF4-FFF2-40B4-BE49-F238E27FC236}">
+                <a16:creationId xmlns:a16="http://schemas.microsoft.com/office/drawing/2014/main" id="{C8F46744-08AA-4FDA-9050-49C076C77E40}"/>
+              </a:ext>
+            </a:extLst>
+          </p:cNvPr>
+          <p:cNvSpPr txBox="1"/>
+          <p:nvPr/>
+        </p:nvSpPr>
+        <p:spPr>
+          <a:xfrm>
+            <a:off x="108003" y="1949305"/>
+            <a:ext cx="1113425" cy="88873"/>
+          </a:xfrm>
+          <a:prstGeom prst="rect">
+            <a:avLst/>
+          </a:prstGeom>
+          <a:noFill/>
+          <a:ln w="9525" cmpd="sng">
+            <a:noFill/>
+          </a:ln>
+        </p:spPr>
+        <p:style>
+          <a:lnRef idx="0">
+            <a:scrgbClr r="0" g="0" b="0"/>
+          </a:lnRef>
+          <a:fillRef idx="0">
+            <a:scrgbClr r="0" g="0" b="0"/>
+          </a:fillRef>
+          <a:effectRef idx="0">
+            <a:scrgbClr r="0" g="0" b="0"/>
+          </a:effectRef>
+          <a:fontRef idx="minor">
+            <a:schemeClr val="dk1"/>
+          </a:fontRef>
+        </p:style>
+        <p:txBody>
+          <a:bodyPr wrap="square" lIns="0" tIns="0" rIns="0" bIns="0" rtlCol="0" anchor="ctr"/>
+          <a:lstStyle>
+            <a:lvl1pPr marL="0" indent="0">
+              <a:defRPr sz="1100">
+                <a:solidFill>
+                  <a:schemeClr val="dk1"/>
+                </a:solidFill>
+                <a:latin typeface="+mn-lt"/>
+                <a:ea typeface="+mn-ea"/>
+                <a:cs typeface="+mn-cs"/>
+              </a:defRPr>
+            </a:lvl1pPr>
+            <a:lvl2pPr marL="457200" indent="0">
+              <a:defRPr sz="1100">
+                <a:solidFill>
+                  <a:schemeClr val="dk1"/>
+                </a:solidFill>
+                <a:latin typeface="+mn-lt"/>
+                <a:ea typeface="+mn-ea"/>
+                <a:cs typeface="+mn-cs"/>
+              </a:defRPr>
+            </a:lvl2pPr>
+            <a:lvl3pPr marL="914400" indent="0">
+              <a:defRPr sz="1100">
+                <a:solidFill>
+                  <a:schemeClr val="dk1"/>
+                </a:solidFill>
+                <a:latin typeface="+mn-lt"/>
+                <a:ea typeface="+mn-ea"/>
+                <a:cs typeface="+mn-cs"/>
+              </a:defRPr>
+            </a:lvl3pPr>
+            <a:lvl4pPr marL="1371600" indent="0">
+              <a:defRPr sz="1100">
+                <a:solidFill>
+                  <a:schemeClr val="dk1"/>
+                </a:solidFill>
+                <a:latin typeface="+mn-lt"/>
+                <a:ea typeface="+mn-ea"/>
+                <a:cs typeface="+mn-cs"/>
+              </a:defRPr>
+            </a:lvl4pPr>
+            <a:lvl5pPr marL="1828800" indent="0">
+              <a:defRPr sz="1100">
+                <a:solidFill>
+                  <a:schemeClr val="dk1"/>
+                </a:solidFill>
+                <a:latin typeface="+mn-lt"/>
+                <a:ea typeface="+mn-ea"/>
+                <a:cs typeface="+mn-cs"/>
+              </a:defRPr>
+            </a:lvl5pPr>
+            <a:lvl6pPr marL="2286000" indent="0">
+              <a:defRPr sz="1100">
+                <a:solidFill>
+                  <a:schemeClr val="dk1"/>
+                </a:solidFill>
+                <a:latin typeface="+mn-lt"/>
+                <a:ea typeface="+mn-ea"/>
+                <a:cs typeface="+mn-cs"/>
+              </a:defRPr>
+            </a:lvl6pPr>
+            <a:lvl7pPr marL="2743200" indent="0">
+              <a:defRPr sz="1100">
+                <a:solidFill>
+                  <a:schemeClr val="dk1"/>
+                </a:solidFill>
+                <a:latin typeface="+mn-lt"/>
+                <a:ea typeface="+mn-ea"/>
+                <a:cs typeface="+mn-cs"/>
+              </a:defRPr>
+            </a:lvl7pPr>
+            <a:lvl8pPr marL="3200400" indent="0">
+              <a:defRPr sz="1100">
+                <a:solidFill>
+                  <a:schemeClr val="dk1"/>
+                </a:solidFill>
+                <a:latin typeface="+mn-lt"/>
+                <a:ea typeface="+mn-ea"/>
+                <a:cs typeface="+mn-cs"/>
+              </a:defRPr>
+            </a:lvl8pPr>
+            <a:lvl9pPr marL="3657600" indent="0">
+              <a:defRPr sz="1100">
+                <a:solidFill>
+                  <a:schemeClr val="dk1"/>
+                </a:solidFill>
+                <a:latin typeface="+mn-lt"/>
+                <a:ea typeface="+mn-ea"/>
+                <a:cs typeface="+mn-cs"/>
+              </a:defRPr>
+            </a:lvl9pPr>
+          </a:lstStyle>
+          <a:p>
+            <a:endParaRPr lang="en-US" sz="1000" b="1" dirty="0">
               <a:latin typeface="Arial Narrow" panose="020B0606020202030204" pitchFamily="34" charset="0"/>
               <a:cs typeface="Arial" panose="020B0604020202020204" pitchFamily="34" charset="0"/>
             </a:endParaRPr>
@@ -4509,8 +4654,8 @@
         </p:nvSpPr>
         <p:spPr bwMode="auto">
           <a:xfrm>
-            <a:off x="16569" y="1397729"/>
-            <a:ext cx="760579" cy="897004"/>
+            <a:off x="16569" y="1790072"/>
+            <a:ext cx="760579" cy="878122"/>
           </a:xfrm>
           <a:prstGeom prst="rect">
             <a:avLst/>
@@ -4527,6 +4672,9 @@
           <a:lstStyle/>
           <a:p>
             <a:pPr marL="55880" marR="0" indent="8890">
+              <a:lnSpc>
+                <a:spcPct val="150000"/>
+              </a:lnSpc>
               <a:spcBef>
                 <a:spcPts val="0"/>
               </a:spcBef>
@@ -4535,15 +4683,13 @@
               </a:spcAft>
             </a:pPr>
             <a:r>
-              <a:rPr lang="hi-IN" sz="800" b="1" dirty="0">
-                <a:latin typeface="Arial Narrow" panose="020B0606020202030204" pitchFamily="34" charset="0"/>
+              <a:rPr lang="hi-IN" sz="900" dirty="0">
                 <a:cs typeface="Arial" panose="020B0604020202020204" pitchFamily="34" charset="0"/>
               </a:rPr>
               <a:t>नाम</a:t>
             </a:r>
             <a:r>
-              <a:rPr lang="en-US" sz="800" b="1" dirty="0">
-                <a:latin typeface="Arial Narrow" panose="020B0606020202030204" pitchFamily="34" charset="0"/>
+              <a:rPr lang="en-US" sz="900" dirty="0">
                 <a:cs typeface="Arial" panose="020B0604020202020204" pitchFamily="34" charset="0"/>
               </a:rPr>
               <a:t>			:</a:t>
@@ -4551,6 +4697,9 @@
           </a:p>
           <a:p>
             <a:pPr marL="55880" marR="0" indent="8890">
+              <a:lnSpc>
+                <a:spcPct val="150000"/>
+              </a:lnSpc>
               <a:spcBef>
                 <a:spcPts val="0"/>
               </a:spcBef>
@@ -4559,72 +4708,30 @@
               </a:spcAft>
             </a:pPr>
             <a:r>
-              <a:rPr lang="en-US" sz="800" b="1" dirty="0">
+              <a:rPr lang="hi-IN" sz="900" dirty="0">
                 <a:effectLst/>
-                <a:latin typeface="Arial Narrow" panose="020B0606020202030204" pitchFamily="34" charset="0"/>
                 <a:ea typeface="Arial" panose="020B0604020202020204" pitchFamily="34" charset="0"/>
               </a:rPr>
-              <a:t>Plant			:</a:t>
-            </a:r>
-            <a:endParaRPr lang="en-US" sz="800" b="1" dirty="0">
-              <a:latin typeface="Arial Narrow" panose="020B0606020202030204" pitchFamily="34" charset="0"/>
-              <a:ea typeface="Arial" panose="020B0604020202020204" pitchFamily="34" charset="0"/>
-            </a:endParaRPr>
-          </a:p>
-          <a:p>
-            <a:pPr marL="55880" indent="8890"/>
-            <a:r>
-              <a:rPr lang="en-IN" sz="800" b="1" kern="100" dirty="0" err="1">
-                <a:solidFill>
-                  <a:srgbClr val="000000"/>
-                </a:solidFill>
+              <a:t>कार्ड नंबर</a:t>
+            </a:r>
+            <a:r>
+              <a:rPr lang="en-US" sz="900" dirty="0">
                 <a:effectLst/>
-                <a:latin typeface="Arial Narrow" panose="020B0606020202030204" pitchFamily="34" charset="0"/>
-                <a:ea typeface="Times New Roman" panose="02020603050405020304" pitchFamily="18" charset="0"/>
+                <a:ea typeface="Arial" panose="020B0604020202020204" pitchFamily="34" charset="0"/>
               </a:rPr>
-              <a:t>नियुक्ति</a:t>
-            </a:r>
-            <a:r>
-              <a:rPr lang="en-IN" sz="800" b="1" kern="100" dirty="0">
-                <a:solidFill>
-                  <a:srgbClr val="000000"/>
-                </a:solidFill>
-                <a:latin typeface="Arial Narrow" panose="020B0606020202030204" pitchFamily="34" charset="0"/>
-                <a:ea typeface="Times New Roman" panose="02020603050405020304" pitchFamily="18" charset="0"/>
-              </a:rPr>
-              <a:t> </a:t>
-            </a:r>
-            <a:r>
-              <a:rPr lang="hi-IN" sz="800" b="1" kern="100" dirty="0">
-                <a:solidFill>
-                  <a:srgbClr val="000000"/>
-                </a:solidFill>
-                <a:effectLst/>
-                <a:latin typeface="Arial Narrow" panose="020B0606020202030204" pitchFamily="34" charset="0"/>
-                <a:ea typeface="Times New Roman" panose="02020603050405020304" pitchFamily="18" charset="0"/>
-              </a:rPr>
-              <a:t>दिनांक</a:t>
-            </a:r>
-            <a:r>
-              <a:rPr lang="en-US" sz="800" b="1" kern="100" dirty="0">
-                <a:solidFill>
-                  <a:srgbClr val="000000"/>
-                </a:solidFill>
-                <a:effectLst/>
-                <a:latin typeface="Arial Narrow" panose="020B0606020202030204" pitchFamily="34" charset="0"/>
-                <a:ea typeface="Times New Roman" panose="02020603050405020304" pitchFamily="18" charset="0"/>
-              </a:rPr>
-              <a:t>	:</a:t>
-            </a:r>
-            <a:endParaRPr lang="en-US" sz="800" b="1" dirty="0">
+              <a:t>		:</a:t>
+            </a:r>
+            <a:endParaRPr lang="en-US" sz="900" dirty="0">
               <a:effectLst/>
-              <a:latin typeface="Arial Narrow" panose="020B0606020202030204" pitchFamily="34" charset="0"/>
               <a:ea typeface="Arial" panose="020B0604020202020204" pitchFamily="34" charset="0"/>
               <a:cs typeface="Arial" panose="020B0604020202020204" pitchFamily="34" charset="0"/>
             </a:endParaRPr>
           </a:p>
           <a:p>
             <a:pPr marL="55880" marR="0" indent="8890">
+              <a:lnSpc>
+                <a:spcPct val="150000"/>
+              </a:lnSpc>
               <a:spcBef>
                 <a:spcPts val="0"/>
               </a:spcBef>
@@ -4633,25 +4740,28 @@
               </a:spcAft>
             </a:pPr>
             <a:r>
-              <a:rPr lang="hi-IN" sz="800" b="1" dirty="0">
-                <a:latin typeface="Arial Narrow" panose="020B0606020202030204" pitchFamily="34" charset="0"/>
+              <a:rPr lang="hi-IN" sz="900" dirty="0">
+                <a:effectLst/>
+                <a:ea typeface="Arial" panose="020B0604020202020204" pitchFamily="34" charset="0"/>
               </a:rPr>
-              <a:t>जन्मदिन</a:t>
-            </a:r>
-            <a:r>
-              <a:rPr lang="en-US" sz="800" b="1" dirty="0">
-                <a:latin typeface="Arial Narrow" panose="020B0606020202030204" pitchFamily="34" charset="0"/>
+              <a:t>विभाग</a:t>
+            </a:r>
+            <a:r>
+              <a:rPr lang="en-US" sz="900" dirty="0">
+                <a:ea typeface="Arial" panose="020B0604020202020204" pitchFamily="34" charset="0"/>
               </a:rPr>
               <a:t>		:</a:t>
             </a:r>
-            <a:endParaRPr lang="en-US" sz="800" b="1" dirty="0">
+            <a:endParaRPr lang="en-US" sz="900" dirty="0">
               <a:effectLst/>
-              <a:latin typeface="Arial Narrow" panose="020B0606020202030204" pitchFamily="34" charset="0"/>
               <a:ea typeface="Arial" panose="020B0604020202020204" pitchFamily="34" charset="0"/>
             </a:endParaRPr>
           </a:p>
           <a:p>
             <a:pPr marL="55880" marR="0" indent="8890">
+              <a:lnSpc>
+                <a:spcPct val="150000"/>
+              </a:lnSpc>
               <a:spcBef>
                 <a:spcPts val="0"/>
               </a:spcBef>
@@ -4660,62 +4770,45 @@
               </a:spcAft>
             </a:pPr>
             <a:r>
-              <a:rPr lang="hi-IN" sz="800" b="1" dirty="0">
-                <a:latin typeface="Arial Narrow" panose="020B0606020202030204" pitchFamily="34" charset="0"/>
+              <a:rPr lang="en-IN" sz="900" kern="100" dirty="0" err="1">
+                <a:solidFill>
+                  <a:srgbClr val="000000"/>
+                </a:solidFill>
+                <a:effectLst/>
+                <a:ea typeface="Times New Roman" panose="02020603050405020304" pitchFamily="18" charset="0"/>
               </a:rPr>
-              <a:t>पिता</a:t>
-            </a:r>
-            <a:r>
-              <a:rPr lang="en-US" sz="800" b="1" dirty="0">
-                <a:latin typeface="Arial Narrow" panose="020B0606020202030204" pitchFamily="34" charset="0"/>
+              <a:t>नियुक्ति</a:t>
+            </a:r>
+            <a:r>
+              <a:rPr lang="en-IN" sz="900" kern="100" dirty="0">
+                <a:solidFill>
+                  <a:srgbClr val="000000"/>
+                </a:solidFill>
+                <a:ea typeface="Times New Roman" panose="02020603050405020304" pitchFamily="18" charset="0"/>
               </a:rPr>
               <a:t> </a:t>
             </a:r>
             <a:r>
-              <a:rPr lang="hi-IN" sz="800" b="1" dirty="0">
-                <a:latin typeface="Arial Narrow" panose="020B0606020202030204" pitchFamily="34" charset="0"/>
+              <a:rPr lang="hi-IN" sz="900" kern="100" dirty="0">
+                <a:solidFill>
+                  <a:srgbClr val="000000"/>
+                </a:solidFill>
+                <a:effectLst/>
+                <a:ea typeface="Times New Roman" panose="02020603050405020304" pitchFamily="18" charset="0"/>
               </a:rPr>
-              <a:t>का नाम</a:t>
-            </a:r>
-            <a:r>
-              <a:rPr lang="en-US" sz="800" b="1" dirty="0">
-                <a:latin typeface="Arial Narrow" panose="020B0606020202030204" pitchFamily="34" charset="0"/>
+              <a:t>दिनांक</a:t>
+            </a:r>
+            <a:r>
+              <a:rPr lang="en-US" sz="900" kern="100" dirty="0">
+                <a:solidFill>
+                  <a:srgbClr val="000000"/>
+                </a:solidFill>
+                <a:ea typeface="Times New Roman" panose="02020603050405020304" pitchFamily="18" charset="0"/>
               </a:rPr>
-              <a:t>	:</a:t>
-            </a:r>
-          </a:p>
-          <a:p>
-            <a:pPr marL="55880" marR="0" indent="8890">
-              <a:spcBef>
-                <a:spcPts val="0"/>
-              </a:spcBef>
-              <a:spcAft>
-                <a:spcPts val="0"/>
-              </a:spcAft>
-            </a:pPr>
-            <a:endParaRPr lang="en-US" sz="800" b="1" dirty="0">
+              <a:t>:</a:t>
+            </a:r>
+            <a:endParaRPr lang="en-US" sz="900" dirty="0">
               <a:effectLst/>
-              <a:latin typeface="Arial Narrow" panose="020B0606020202030204" pitchFamily="34" charset="0"/>
-              <a:ea typeface="Arial" panose="020B0604020202020204" pitchFamily="34" charset="0"/>
-            </a:endParaRPr>
-          </a:p>
-          <a:p>
-            <a:pPr marL="55880" indent="8890"/>
-            <a:r>
-              <a:rPr lang="hi-IN" sz="800" b="1" dirty="0">
-                <a:latin typeface="Arial Narrow" panose="020B0606020202030204" pitchFamily="34" charset="0"/>
-              </a:rPr>
-              <a:t>पता</a:t>
-            </a:r>
-            <a:r>
-              <a:rPr lang="en-US" sz="800" b="1" dirty="0">
-                <a:latin typeface="Arial Narrow" panose="020B0606020202030204" pitchFamily="34" charset="0"/>
-              </a:rPr>
-              <a:t> :</a:t>
-            </a:r>
-            <a:endParaRPr lang="en-US" sz="800" b="1" dirty="0">
-              <a:effectLst/>
-              <a:latin typeface="Arial Narrow" panose="020B0606020202030204" pitchFamily="34" charset="0"/>
               <a:ea typeface="Arial" panose="020B0604020202020204" pitchFamily="34" charset="0"/>
             </a:endParaRPr>
           </a:p>
@@ -4743,8 +4836,8 @@
         </p:blipFill>
         <p:spPr>
           <a:xfrm>
-            <a:off x="46790" y="150222"/>
-            <a:ext cx="354670" cy="394679"/>
+            <a:off x="695286" y="49135"/>
+            <a:ext cx="441183" cy="412872"/>
           </a:xfrm>
           <a:prstGeom prst="rect">
             <a:avLst/>
@@ -4765,8 +4858,8 @@
         </p:nvSpPr>
         <p:spPr>
           <a:xfrm>
-            <a:off x="409059" y="297379"/>
-            <a:ext cx="1522234" cy="253916"/>
+            <a:off x="135505" y="442526"/>
+            <a:ext cx="1732451" cy="276999"/>
           </a:xfrm>
           <a:prstGeom prst="rect">
             <a:avLst/>
@@ -4780,14 +4873,10 @@
           <a:lstStyle/>
           <a:p>
             <a:r>
-              <a:rPr lang="hi-IN" sz="1050" b="1" dirty="0">
-                <a:latin typeface="Arial Narrow" panose="020B0606020202030204" pitchFamily="34" charset="0"/>
-              </a:rPr>
+              <a:rPr lang="hi-IN" sz="1200" b="1" dirty="0"/>
               <a:t>प्रतिभा सिंटेक्स लिमिटेड</a:t>
             </a:r>
-            <a:endParaRPr lang="en-US" sz="1050" b="1" dirty="0">
-              <a:latin typeface="Arial Narrow" panose="020B0606020202030204" pitchFamily="34" charset="0"/>
-            </a:endParaRPr>
+            <a:endParaRPr lang="en-US" sz="1200" b="1" dirty="0"/>
           </a:p>
         </p:txBody>
       </p:sp>
@@ -4839,1401 +4928,16 @@
           <a:lstStyle/>
           <a:p>
             <a:pPr algn="ctr"/>
-            <a:endParaRPr lang="en-US" sz="800" b="1" dirty="0">
-              <a:latin typeface="Arial Narrow" panose="020B0606020202030204" pitchFamily="34" charset="0"/>
-            </a:endParaRPr>
-          </a:p>
-        </p:txBody>
-      </p:sp>
-      <p:sp>
-        <p:nvSpPr>
-          <p:cNvPr id="17" name="ID">
+            <a:endParaRPr lang="en-US" sz="600" dirty="0"/>
+          </a:p>
+        </p:txBody>
+      </p:sp>
+      <p:pic>
+        <p:nvPicPr>
+          <p:cNvPr id="3" name="Picture 2">
             <a:extLst>
               <a:ext uri="{FF2B5EF4-FFF2-40B4-BE49-F238E27FC236}">
-                <a16:creationId xmlns:a16="http://schemas.microsoft.com/office/drawing/2014/main" id="{A78EBDF8-1EBE-481C-88A9-8FB1E1F41C79}"/>
-              </a:ext>
-            </a:extLst>
-          </p:cNvPr>
-          <p:cNvSpPr txBox="1"/>
-          <p:nvPr/>
-        </p:nvSpPr>
-        <p:spPr>
-          <a:xfrm>
-            <a:off x="790306" y="1129531"/>
-            <a:ext cx="554053" cy="112520"/>
-          </a:xfrm>
-          <a:prstGeom prst="rect">
-            <a:avLst/>
-          </a:prstGeom>
-          <a:noFill/>
-          <a:ln w="9525" cmpd="sng">
-            <a:noFill/>
-          </a:ln>
-        </p:spPr>
-        <p:style>
-          <a:lnRef idx="0">
-            <a:scrgbClr r="0" g="0" b="0"/>
-          </a:lnRef>
-          <a:fillRef idx="0">
-            <a:scrgbClr r="0" g="0" b="0"/>
-          </a:fillRef>
-          <a:effectRef idx="0">
-            <a:scrgbClr r="0" g="0" b="0"/>
-          </a:effectRef>
-          <a:fontRef idx="minor">
-            <a:schemeClr val="dk1"/>
-          </a:fontRef>
-        </p:style>
-        <p:txBody>
-          <a:bodyPr wrap="square" lIns="0" tIns="0" rIns="0" bIns="0" rtlCol="0" anchor="ctr"/>
-          <a:lstStyle>
-            <a:lvl1pPr marL="0" indent="0">
-              <a:defRPr sz="1100">
-                <a:solidFill>
-                  <a:schemeClr val="dk1"/>
-                </a:solidFill>
-                <a:latin typeface="+mn-lt"/>
-                <a:ea typeface="+mn-ea"/>
-                <a:cs typeface="+mn-cs"/>
-              </a:defRPr>
-            </a:lvl1pPr>
-            <a:lvl2pPr marL="457200" indent="0">
-              <a:defRPr sz="1100">
-                <a:solidFill>
-                  <a:schemeClr val="dk1"/>
-                </a:solidFill>
-                <a:latin typeface="+mn-lt"/>
-                <a:ea typeface="+mn-ea"/>
-                <a:cs typeface="+mn-cs"/>
-              </a:defRPr>
-            </a:lvl2pPr>
-            <a:lvl3pPr marL="914400" indent="0">
-              <a:defRPr sz="1100">
-                <a:solidFill>
-                  <a:schemeClr val="dk1"/>
-                </a:solidFill>
-                <a:latin typeface="+mn-lt"/>
-                <a:ea typeface="+mn-ea"/>
-                <a:cs typeface="+mn-cs"/>
-              </a:defRPr>
-            </a:lvl3pPr>
-            <a:lvl4pPr marL="1371600" indent="0">
-              <a:defRPr sz="1100">
-                <a:solidFill>
-                  <a:schemeClr val="dk1"/>
-                </a:solidFill>
-                <a:latin typeface="+mn-lt"/>
-                <a:ea typeface="+mn-ea"/>
-                <a:cs typeface="+mn-cs"/>
-              </a:defRPr>
-            </a:lvl4pPr>
-            <a:lvl5pPr marL="1828800" indent="0">
-              <a:defRPr sz="1100">
-                <a:solidFill>
-                  <a:schemeClr val="dk1"/>
-                </a:solidFill>
-                <a:latin typeface="+mn-lt"/>
-                <a:ea typeface="+mn-ea"/>
-                <a:cs typeface="+mn-cs"/>
-              </a:defRPr>
-            </a:lvl5pPr>
-            <a:lvl6pPr marL="2286000" indent="0">
-              <a:defRPr sz="1100">
-                <a:solidFill>
-                  <a:schemeClr val="dk1"/>
-                </a:solidFill>
-                <a:latin typeface="+mn-lt"/>
-                <a:ea typeface="+mn-ea"/>
-                <a:cs typeface="+mn-cs"/>
-              </a:defRPr>
-            </a:lvl6pPr>
-            <a:lvl7pPr marL="2743200" indent="0">
-              <a:defRPr sz="1100">
-                <a:solidFill>
-                  <a:schemeClr val="dk1"/>
-                </a:solidFill>
-                <a:latin typeface="+mn-lt"/>
-                <a:ea typeface="+mn-ea"/>
-                <a:cs typeface="+mn-cs"/>
-              </a:defRPr>
-            </a:lvl7pPr>
-            <a:lvl8pPr marL="3200400" indent="0">
-              <a:defRPr sz="1100">
-                <a:solidFill>
-                  <a:schemeClr val="dk1"/>
-                </a:solidFill>
-                <a:latin typeface="+mn-lt"/>
-                <a:ea typeface="+mn-ea"/>
-                <a:cs typeface="+mn-cs"/>
-              </a:defRPr>
-            </a:lvl8pPr>
-            <a:lvl9pPr marL="3657600" indent="0">
-              <a:defRPr sz="1100">
-                <a:solidFill>
-                  <a:schemeClr val="dk1"/>
-                </a:solidFill>
-                <a:latin typeface="+mn-lt"/>
-                <a:ea typeface="+mn-ea"/>
-                <a:cs typeface="+mn-cs"/>
-              </a:defRPr>
-            </a:lvl9pPr>
-          </a:lstStyle>
-          <a:p>
-            <a:r>
-              <a:rPr lang="hi-IN" sz="800" b="1" dirty="0">
-                <a:effectLst/>
-                <a:latin typeface="Arial Narrow" panose="020B0606020202030204" pitchFamily="34" charset="0"/>
-                <a:ea typeface="Arial" panose="020B0604020202020204" pitchFamily="34" charset="0"/>
-              </a:rPr>
-              <a:t>कार्ड नंबर</a:t>
-            </a:r>
-            <a:r>
-              <a:rPr lang="en-US" sz="800" b="1" dirty="0">
-                <a:effectLst/>
-                <a:latin typeface="Arial Narrow" panose="020B0606020202030204" pitchFamily="34" charset="0"/>
-                <a:ea typeface="Arial" panose="020B0604020202020204" pitchFamily="34" charset="0"/>
-              </a:rPr>
-              <a:t>:	</a:t>
-            </a:r>
-            <a:endParaRPr lang="en-US" sz="800" b="1" dirty="0">
-              <a:latin typeface="Arial Narrow" panose="020B0606020202030204" pitchFamily="34" charset="0"/>
-              <a:cs typeface="Arial" panose="020B0604020202020204" pitchFamily="34" charset="0"/>
-            </a:endParaRPr>
-          </a:p>
-        </p:txBody>
-      </p:sp>
-      <p:sp>
-        <p:nvSpPr>
-          <p:cNvPr id="19" name="ID">
-            <a:extLst>
-              <a:ext uri="{FF2B5EF4-FFF2-40B4-BE49-F238E27FC236}">
-                <a16:creationId xmlns:a16="http://schemas.microsoft.com/office/drawing/2014/main" id="{B9E2181F-5D30-40E5-81CE-4DC7D47D1745}"/>
-              </a:ext>
-            </a:extLst>
-          </p:cNvPr>
-          <p:cNvSpPr txBox="1"/>
-          <p:nvPr/>
-        </p:nvSpPr>
-        <p:spPr>
-          <a:xfrm>
-            <a:off x="796394" y="1261376"/>
-            <a:ext cx="523281" cy="112520"/>
-          </a:xfrm>
-          <a:prstGeom prst="rect">
-            <a:avLst/>
-          </a:prstGeom>
-          <a:noFill/>
-          <a:ln w="9525" cmpd="sng">
-            <a:noFill/>
-          </a:ln>
-        </p:spPr>
-        <p:style>
-          <a:lnRef idx="0">
-            <a:scrgbClr r="0" g="0" b="0"/>
-          </a:lnRef>
-          <a:fillRef idx="0">
-            <a:scrgbClr r="0" g="0" b="0"/>
-          </a:fillRef>
-          <a:effectRef idx="0">
-            <a:scrgbClr r="0" g="0" b="0"/>
-          </a:effectRef>
-          <a:fontRef idx="minor">
-            <a:schemeClr val="dk1"/>
-          </a:fontRef>
-        </p:style>
-        <p:txBody>
-          <a:bodyPr wrap="square" lIns="0" tIns="0" rIns="0" bIns="0" rtlCol="0" anchor="ctr"/>
-          <a:lstStyle>
-            <a:lvl1pPr marL="0" indent="0">
-              <a:defRPr sz="1100">
-                <a:solidFill>
-                  <a:schemeClr val="dk1"/>
-                </a:solidFill>
-                <a:latin typeface="+mn-lt"/>
-                <a:ea typeface="+mn-ea"/>
-                <a:cs typeface="+mn-cs"/>
-              </a:defRPr>
-            </a:lvl1pPr>
-            <a:lvl2pPr marL="457200" indent="0">
-              <a:defRPr sz="1100">
-                <a:solidFill>
-                  <a:schemeClr val="dk1"/>
-                </a:solidFill>
-                <a:latin typeface="+mn-lt"/>
-                <a:ea typeface="+mn-ea"/>
-                <a:cs typeface="+mn-cs"/>
-              </a:defRPr>
-            </a:lvl2pPr>
-            <a:lvl3pPr marL="914400" indent="0">
-              <a:defRPr sz="1100">
-                <a:solidFill>
-                  <a:schemeClr val="dk1"/>
-                </a:solidFill>
-                <a:latin typeface="+mn-lt"/>
-                <a:ea typeface="+mn-ea"/>
-                <a:cs typeface="+mn-cs"/>
-              </a:defRPr>
-            </a:lvl3pPr>
-            <a:lvl4pPr marL="1371600" indent="0">
-              <a:defRPr sz="1100">
-                <a:solidFill>
-                  <a:schemeClr val="dk1"/>
-                </a:solidFill>
-                <a:latin typeface="+mn-lt"/>
-                <a:ea typeface="+mn-ea"/>
-                <a:cs typeface="+mn-cs"/>
-              </a:defRPr>
-            </a:lvl4pPr>
-            <a:lvl5pPr marL="1828800" indent="0">
-              <a:defRPr sz="1100">
-                <a:solidFill>
-                  <a:schemeClr val="dk1"/>
-                </a:solidFill>
-                <a:latin typeface="+mn-lt"/>
-                <a:ea typeface="+mn-ea"/>
-                <a:cs typeface="+mn-cs"/>
-              </a:defRPr>
-            </a:lvl5pPr>
-            <a:lvl6pPr marL="2286000" indent="0">
-              <a:defRPr sz="1100">
-                <a:solidFill>
-                  <a:schemeClr val="dk1"/>
-                </a:solidFill>
-                <a:latin typeface="+mn-lt"/>
-                <a:ea typeface="+mn-ea"/>
-                <a:cs typeface="+mn-cs"/>
-              </a:defRPr>
-            </a:lvl6pPr>
-            <a:lvl7pPr marL="2743200" indent="0">
-              <a:defRPr sz="1100">
-                <a:solidFill>
-                  <a:schemeClr val="dk1"/>
-                </a:solidFill>
-                <a:latin typeface="+mn-lt"/>
-                <a:ea typeface="+mn-ea"/>
-                <a:cs typeface="+mn-cs"/>
-              </a:defRPr>
-            </a:lvl7pPr>
-            <a:lvl8pPr marL="3200400" indent="0">
-              <a:defRPr sz="1100">
-                <a:solidFill>
-                  <a:schemeClr val="dk1"/>
-                </a:solidFill>
-                <a:latin typeface="+mn-lt"/>
-                <a:ea typeface="+mn-ea"/>
-                <a:cs typeface="+mn-cs"/>
-              </a:defRPr>
-            </a:lvl8pPr>
-            <a:lvl9pPr marL="3657600" indent="0">
-              <a:defRPr sz="1100">
-                <a:solidFill>
-                  <a:schemeClr val="dk1"/>
-                </a:solidFill>
-                <a:latin typeface="+mn-lt"/>
-                <a:ea typeface="+mn-ea"/>
-                <a:cs typeface="+mn-cs"/>
-              </a:defRPr>
-            </a:lvl9pPr>
-          </a:lstStyle>
-          <a:p>
-            <a:r>
-              <a:rPr lang="hi-IN" sz="800" b="1" dirty="0">
-                <a:latin typeface="Arial Narrow" panose="020B0606020202030204" pitchFamily="34" charset="0"/>
-              </a:rPr>
-              <a:t>रक्त समूह</a:t>
-            </a:r>
-            <a:r>
-              <a:rPr lang="en-US" sz="800" b="1" dirty="0">
-                <a:effectLst/>
-                <a:latin typeface="Arial Narrow" panose="020B0606020202030204" pitchFamily="34" charset="0"/>
-                <a:ea typeface="Arial" panose="020B0604020202020204" pitchFamily="34" charset="0"/>
-              </a:rPr>
-              <a:t>:</a:t>
-            </a:r>
-            <a:endParaRPr lang="en-US" sz="800" b="1" dirty="0">
-              <a:latin typeface="Arial Narrow" panose="020B0606020202030204" pitchFamily="34" charset="0"/>
-              <a:cs typeface="Arial" panose="020B0604020202020204" pitchFamily="34" charset="0"/>
-            </a:endParaRPr>
-          </a:p>
-        </p:txBody>
-      </p:sp>
-      <p:sp>
-        <p:nvSpPr>
-          <p:cNvPr id="20" name="BloodGroup">
-            <a:extLst>
-              <a:ext uri="{FF2B5EF4-FFF2-40B4-BE49-F238E27FC236}">
-                <a16:creationId xmlns:a16="http://schemas.microsoft.com/office/drawing/2014/main" id="{61EB8762-CC20-4BE5-B3F7-2E8AAF846E44}"/>
-              </a:ext>
-            </a:extLst>
-          </p:cNvPr>
-          <p:cNvSpPr txBox="1"/>
-          <p:nvPr/>
-        </p:nvSpPr>
-        <p:spPr>
-          <a:xfrm>
-            <a:off x="1248379" y="1240594"/>
-            <a:ext cx="560798" cy="132913"/>
-          </a:xfrm>
-          <a:prstGeom prst="rect">
-            <a:avLst/>
-          </a:prstGeom>
-          <a:noFill/>
-          <a:ln w="9525" cmpd="sng">
-            <a:noFill/>
-          </a:ln>
-        </p:spPr>
-        <p:style>
-          <a:lnRef idx="0">
-            <a:scrgbClr r="0" g="0" b="0"/>
-          </a:lnRef>
-          <a:fillRef idx="0">
-            <a:scrgbClr r="0" g="0" b="0"/>
-          </a:fillRef>
-          <a:effectRef idx="0">
-            <a:scrgbClr r="0" g="0" b="0"/>
-          </a:effectRef>
-          <a:fontRef idx="minor">
-            <a:schemeClr val="dk1"/>
-          </a:fontRef>
-        </p:style>
-        <p:txBody>
-          <a:bodyPr wrap="square" lIns="0" tIns="0" rIns="0" bIns="0" rtlCol="0" anchor="ctr"/>
-          <a:lstStyle>
-            <a:lvl1pPr marL="0" indent="0">
-              <a:defRPr sz="1100">
-                <a:solidFill>
-                  <a:schemeClr val="dk1"/>
-                </a:solidFill>
-                <a:latin typeface="+mn-lt"/>
-                <a:ea typeface="+mn-ea"/>
-                <a:cs typeface="+mn-cs"/>
-              </a:defRPr>
-            </a:lvl1pPr>
-            <a:lvl2pPr marL="457200" indent="0">
-              <a:defRPr sz="1100">
-                <a:solidFill>
-                  <a:schemeClr val="dk1"/>
-                </a:solidFill>
-                <a:latin typeface="+mn-lt"/>
-                <a:ea typeface="+mn-ea"/>
-                <a:cs typeface="+mn-cs"/>
-              </a:defRPr>
-            </a:lvl2pPr>
-            <a:lvl3pPr marL="914400" indent="0">
-              <a:defRPr sz="1100">
-                <a:solidFill>
-                  <a:schemeClr val="dk1"/>
-                </a:solidFill>
-                <a:latin typeface="+mn-lt"/>
-                <a:ea typeface="+mn-ea"/>
-                <a:cs typeface="+mn-cs"/>
-              </a:defRPr>
-            </a:lvl3pPr>
-            <a:lvl4pPr marL="1371600" indent="0">
-              <a:defRPr sz="1100">
-                <a:solidFill>
-                  <a:schemeClr val="dk1"/>
-                </a:solidFill>
-                <a:latin typeface="+mn-lt"/>
-                <a:ea typeface="+mn-ea"/>
-                <a:cs typeface="+mn-cs"/>
-              </a:defRPr>
-            </a:lvl4pPr>
-            <a:lvl5pPr marL="1828800" indent="0">
-              <a:defRPr sz="1100">
-                <a:solidFill>
-                  <a:schemeClr val="dk1"/>
-                </a:solidFill>
-                <a:latin typeface="+mn-lt"/>
-                <a:ea typeface="+mn-ea"/>
-                <a:cs typeface="+mn-cs"/>
-              </a:defRPr>
-            </a:lvl5pPr>
-            <a:lvl6pPr marL="2286000" indent="0">
-              <a:defRPr sz="1100">
-                <a:solidFill>
-                  <a:schemeClr val="dk1"/>
-                </a:solidFill>
-                <a:latin typeface="+mn-lt"/>
-                <a:ea typeface="+mn-ea"/>
-                <a:cs typeface="+mn-cs"/>
-              </a:defRPr>
-            </a:lvl6pPr>
-            <a:lvl7pPr marL="2743200" indent="0">
-              <a:defRPr sz="1100">
-                <a:solidFill>
-                  <a:schemeClr val="dk1"/>
-                </a:solidFill>
-                <a:latin typeface="+mn-lt"/>
-                <a:ea typeface="+mn-ea"/>
-                <a:cs typeface="+mn-cs"/>
-              </a:defRPr>
-            </a:lvl7pPr>
-            <a:lvl8pPr marL="3200400" indent="0">
-              <a:defRPr sz="1100">
-                <a:solidFill>
-                  <a:schemeClr val="dk1"/>
-                </a:solidFill>
-                <a:latin typeface="+mn-lt"/>
-                <a:ea typeface="+mn-ea"/>
-                <a:cs typeface="+mn-cs"/>
-              </a:defRPr>
-            </a:lvl8pPr>
-            <a:lvl9pPr marL="3657600" indent="0">
-              <a:defRPr sz="1100">
-                <a:solidFill>
-                  <a:schemeClr val="dk1"/>
-                </a:solidFill>
-                <a:latin typeface="+mn-lt"/>
-                <a:ea typeface="+mn-ea"/>
-                <a:cs typeface="+mn-cs"/>
-              </a:defRPr>
-            </a:lvl9pPr>
-          </a:lstStyle>
-          <a:p>
-            <a:r>
-              <a:rPr lang="en-US" sz="800" b="1" dirty="0">
-                <a:latin typeface="Arial Narrow" panose="020B0606020202030204" pitchFamily="34" charset="0"/>
-                <a:cs typeface="Aharoni" panose="02010803020104030203" pitchFamily="2" charset="-79"/>
-              </a:rPr>
-              <a:t>{BloodGroup}</a:t>
-            </a:r>
-          </a:p>
-        </p:txBody>
-      </p:sp>
-      <p:sp>
-        <p:nvSpPr>
-          <p:cNvPr id="21" name="DOJ">
-            <a:extLst>
-              <a:ext uri="{FF2B5EF4-FFF2-40B4-BE49-F238E27FC236}">
-                <a16:creationId xmlns:a16="http://schemas.microsoft.com/office/drawing/2014/main" id="{D1342B58-F378-400D-A011-E27FC2444B17}"/>
-              </a:ext>
-            </a:extLst>
-          </p:cNvPr>
-          <p:cNvSpPr txBox="1"/>
-          <p:nvPr/>
-        </p:nvSpPr>
-        <p:spPr>
-          <a:xfrm>
-            <a:off x="777148" y="1770614"/>
-            <a:ext cx="942017" cy="117276"/>
-          </a:xfrm>
-          <a:prstGeom prst="rect">
-            <a:avLst/>
-          </a:prstGeom>
-          <a:noFill/>
-          <a:ln w="9525" cmpd="sng">
-            <a:noFill/>
-          </a:ln>
-        </p:spPr>
-        <p:style>
-          <a:lnRef idx="0">
-            <a:scrgbClr r="0" g="0" b="0"/>
-          </a:lnRef>
-          <a:fillRef idx="0">
-            <a:scrgbClr r="0" g="0" b="0"/>
-          </a:fillRef>
-          <a:effectRef idx="0">
-            <a:scrgbClr r="0" g="0" b="0"/>
-          </a:effectRef>
-          <a:fontRef idx="minor">
-            <a:schemeClr val="dk1"/>
-          </a:fontRef>
-        </p:style>
-        <p:txBody>
-          <a:bodyPr wrap="square" lIns="0" tIns="0" rIns="0" bIns="0" rtlCol="0" anchor="ctr"/>
-          <a:lstStyle>
-            <a:lvl1pPr marL="0" indent="0">
-              <a:defRPr sz="1100">
-                <a:solidFill>
-                  <a:schemeClr val="dk1"/>
-                </a:solidFill>
-                <a:latin typeface="+mn-lt"/>
-                <a:ea typeface="+mn-ea"/>
-                <a:cs typeface="+mn-cs"/>
-              </a:defRPr>
-            </a:lvl1pPr>
-            <a:lvl2pPr marL="457200" indent="0">
-              <a:defRPr sz="1100">
-                <a:solidFill>
-                  <a:schemeClr val="dk1"/>
-                </a:solidFill>
-                <a:latin typeface="+mn-lt"/>
-                <a:ea typeface="+mn-ea"/>
-                <a:cs typeface="+mn-cs"/>
-              </a:defRPr>
-            </a:lvl2pPr>
-            <a:lvl3pPr marL="914400" indent="0">
-              <a:defRPr sz="1100">
-                <a:solidFill>
-                  <a:schemeClr val="dk1"/>
-                </a:solidFill>
-                <a:latin typeface="+mn-lt"/>
-                <a:ea typeface="+mn-ea"/>
-                <a:cs typeface="+mn-cs"/>
-              </a:defRPr>
-            </a:lvl3pPr>
-            <a:lvl4pPr marL="1371600" indent="0">
-              <a:defRPr sz="1100">
-                <a:solidFill>
-                  <a:schemeClr val="dk1"/>
-                </a:solidFill>
-                <a:latin typeface="+mn-lt"/>
-                <a:ea typeface="+mn-ea"/>
-                <a:cs typeface="+mn-cs"/>
-              </a:defRPr>
-            </a:lvl4pPr>
-            <a:lvl5pPr marL="1828800" indent="0">
-              <a:defRPr sz="1100">
-                <a:solidFill>
-                  <a:schemeClr val="dk1"/>
-                </a:solidFill>
-                <a:latin typeface="+mn-lt"/>
-                <a:ea typeface="+mn-ea"/>
-                <a:cs typeface="+mn-cs"/>
-              </a:defRPr>
-            </a:lvl5pPr>
-            <a:lvl6pPr marL="2286000" indent="0">
-              <a:defRPr sz="1100">
-                <a:solidFill>
-                  <a:schemeClr val="dk1"/>
-                </a:solidFill>
-                <a:latin typeface="+mn-lt"/>
-                <a:ea typeface="+mn-ea"/>
-                <a:cs typeface="+mn-cs"/>
-              </a:defRPr>
-            </a:lvl6pPr>
-            <a:lvl7pPr marL="2743200" indent="0">
-              <a:defRPr sz="1100">
-                <a:solidFill>
-                  <a:schemeClr val="dk1"/>
-                </a:solidFill>
-                <a:latin typeface="+mn-lt"/>
-                <a:ea typeface="+mn-ea"/>
-                <a:cs typeface="+mn-cs"/>
-              </a:defRPr>
-            </a:lvl7pPr>
-            <a:lvl8pPr marL="3200400" indent="0">
-              <a:defRPr sz="1100">
-                <a:solidFill>
-                  <a:schemeClr val="dk1"/>
-                </a:solidFill>
-                <a:latin typeface="+mn-lt"/>
-                <a:ea typeface="+mn-ea"/>
-                <a:cs typeface="+mn-cs"/>
-              </a:defRPr>
-            </a:lvl8pPr>
-            <a:lvl9pPr marL="3657600" indent="0">
-              <a:defRPr sz="1100">
-                <a:solidFill>
-                  <a:schemeClr val="dk1"/>
-                </a:solidFill>
-                <a:latin typeface="+mn-lt"/>
-                <a:ea typeface="+mn-ea"/>
-                <a:cs typeface="+mn-cs"/>
-              </a:defRPr>
-            </a:lvl9pPr>
-          </a:lstStyle>
-          <a:p>
-            <a:r>
-              <a:rPr lang="en-US" sz="800" b="1" dirty="0">
-                <a:latin typeface="Arial Narrow" panose="020B0606020202030204" pitchFamily="34" charset="0"/>
-                <a:cs typeface="Aharoni" panose="02010803020104030203" pitchFamily="2" charset="-79"/>
-              </a:rPr>
-              <a:t>{DOB}</a:t>
-            </a:r>
-          </a:p>
-        </p:txBody>
-      </p:sp>
-      <p:sp>
-        <p:nvSpPr>
-          <p:cNvPr id="24" name="Department">
-            <a:extLst>
-              <a:ext uri="{FF2B5EF4-FFF2-40B4-BE49-F238E27FC236}">
-                <a16:creationId xmlns:a16="http://schemas.microsoft.com/office/drawing/2014/main" id="{6F2E698A-909E-4F59-B369-CC2E5FF326ED}"/>
-              </a:ext>
-            </a:extLst>
-          </p:cNvPr>
-          <p:cNvSpPr txBox="1"/>
-          <p:nvPr/>
-        </p:nvSpPr>
-        <p:spPr>
-          <a:xfrm>
-            <a:off x="75018" y="2022788"/>
-            <a:ext cx="1121595" cy="95343"/>
-          </a:xfrm>
-          <a:prstGeom prst="rect">
-            <a:avLst/>
-          </a:prstGeom>
-          <a:noFill/>
-          <a:ln w="9525" cmpd="sng">
-            <a:noFill/>
-          </a:ln>
-        </p:spPr>
-        <p:style>
-          <a:lnRef idx="0">
-            <a:scrgbClr r="0" g="0" b="0"/>
-          </a:lnRef>
-          <a:fillRef idx="0">
-            <a:scrgbClr r="0" g="0" b="0"/>
-          </a:fillRef>
-          <a:effectRef idx="0">
-            <a:scrgbClr r="0" g="0" b="0"/>
-          </a:effectRef>
-          <a:fontRef idx="minor">
-            <a:schemeClr val="dk1"/>
-          </a:fontRef>
-        </p:style>
-        <p:txBody>
-          <a:bodyPr wrap="square" lIns="0" tIns="0" rIns="0" bIns="0" rtlCol="0" anchor="ctr"/>
-          <a:lstStyle>
-            <a:lvl1pPr marL="0" indent="0">
-              <a:defRPr sz="1100">
-                <a:solidFill>
-                  <a:schemeClr val="dk1"/>
-                </a:solidFill>
-                <a:latin typeface="+mn-lt"/>
-                <a:ea typeface="+mn-ea"/>
-                <a:cs typeface="+mn-cs"/>
-              </a:defRPr>
-            </a:lvl1pPr>
-            <a:lvl2pPr marL="457200" indent="0">
-              <a:defRPr sz="1100">
-                <a:solidFill>
-                  <a:schemeClr val="dk1"/>
-                </a:solidFill>
-                <a:latin typeface="+mn-lt"/>
-                <a:ea typeface="+mn-ea"/>
-                <a:cs typeface="+mn-cs"/>
-              </a:defRPr>
-            </a:lvl2pPr>
-            <a:lvl3pPr marL="914400" indent="0">
-              <a:defRPr sz="1100">
-                <a:solidFill>
-                  <a:schemeClr val="dk1"/>
-                </a:solidFill>
-                <a:latin typeface="+mn-lt"/>
-                <a:ea typeface="+mn-ea"/>
-                <a:cs typeface="+mn-cs"/>
-              </a:defRPr>
-            </a:lvl3pPr>
-            <a:lvl4pPr marL="1371600" indent="0">
-              <a:defRPr sz="1100">
-                <a:solidFill>
-                  <a:schemeClr val="dk1"/>
-                </a:solidFill>
-                <a:latin typeface="+mn-lt"/>
-                <a:ea typeface="+mn-ea"/>
-                <a:cs typeface="+mn-cs"/>
-              </a:defRPr>
-            </a:lvl4pPr>
-            <a:lvl5pPr marL="1828800" indent="0">
-              <a:defRPr sz="1100">
-                <a:solidFill>
-                  <a:schemeClr val="dk1"/>
-                </a:solidFill>
-                <a:latin typeface="+mn-lt"/>
-                <a:ea typeface="+mn-ea"/>
-                <a:cs typeface="+mn-cs"/>
-              </a:defRPr>
-            </a:lvl5pPr>
-            <a:lvl6pPr marL="2286000" indent="0">
-              <a:defRPr sz="1100">
-                <a:solidFill>
-                  <a:schemeClr val="dk1"/>
-                </a:solidFill>
-                <a:latin typeface="+mn-lt"/>
-                <a:ea typeface="+mn-ea"/>
-                <a:cs typeface="+mn-cs"/>
-              </a:defRPr>
-            </a:lvl6pPr>
-            <a:lvl7pPr marL="2743200" indent="0">
-              <a:defRPr sz="1100">
-                <a:solidFill>
-                  <a:schemeClr val="dk1"/>
-                </a:solidFill>
-                <a:latin typeface="+mn-lt"/>
-                <a:ea typeface="+mn-ea"/>
-                <a:cs typeface="+mn-cs"/>
-              </a:defRPr>
-            </a:lvl7pPr>
-            <a:lvl8pPr marL="3200400" indent="0">
-              <a:defRPr sz="1100">
-                <a:solidFill>
-                  <a:schemeClr val="dk1"/>
-                </a:solidFill>
-                <a:latin typeface="+mn-lt"/>
-                <a:ea typeface="+mn-ea"/>
-                <a:cs typeface="+mn-cs"/>
-              </a:defRPr>
-            </a:lvl8pPr>
-            <a:lvl9pPr marL="3657600" indent="0">
-              <a:defRPr sz="1100">
-                <a:solidFill>
-                  <a:schemeClr val="dk1"/>
-                </a:solidFill>
-                <a:latin typeface="+mn-lt"/>
-                <a:ea typeface="+mn-ea"/>
-                <a:cs typeface="+mn-cs"/>
-              </a:defRPr>
-            </a:lvl9pPr>
-          </a:lstStyle>
-          <a:p>
-            <a:r>
-              <a:rPr lang="hi-IN" sz="800" b="1" dirty="0">
-                <a:latin typeface="Arial Narrow" panose="020B0606020202030204" pitchFamily="34" charset="0"/>
-              </a:rPr>
-              <a:t>आपातकालीन फोन नंबर</a:t>
-            </a:r>
-            <a:r>
-              <a:rPr lang="en-US" sz="800" b="1" dirty="0">
-                <a:latin typeface="Arial Narrow" panose="020B0606020202030204" pitchFamily="34" charset="0"/>
-              </a:rPr>
-              <a:t>:</a:t>
-            </a:r>
-            <a:endParaRPr lang="en-US" sz="800" b="1" dirty="0">
-              <a:latin typeface="Arial Narrow" panose="020B0606020202030204" pitchFamily="34" charset="0"/>
-              <a:cs typeface="Arial" panose="020B0604020202020204" pitchFamily="34" charset="0"/>
-            </a:endParaRPr>
-          </a:p>
-        </p:txBody>
-      </p:sp>
-      <p:sp>
-        <p:nvSpPr>
-          <p:cNvPr id="27" name="PermanentAddress">
-            <a:extLst>
-              <a:ext uri="{FF2B5EF4-FFF2-40B4-BE49-F238E27FC236}">
-                <a16:creationId xmlns:a16="http://schemas.microsoft.com/office/drawing/2014/main" id="{67C3A2FE-F9BF-4E53-90CA-8748A39E5D1C}"/>
-              </a:ext>
-            </a:extLst>
-          </p:cNvPr>
-          <p:cNvSpPr txBox="1"/>
-          <p:nvPr/>
-        </p:nvSpPr>
-        <p:spPr>
-          <a:xfrm>
-            <a:off x="318156" y="2121029"/>
-            <a:ext cx="819974" cy="391919"/>
-          </a:xfrm>
-          <a:prstGeom prst="rect">
-            <a:avLst/>
-          </a:prstGeom>
-          <a:solidFill>
-            <a:schemeClr val="lt1"/>
-          </a:solidFill>
-          <a:ln w="9525" cmpd="sng">
-            <a:noFill/>
-          </a:ln>
-        </p:spPr>
-        <p:style>
-          <a:lnRef idx="0">
-            <a:scrgbClr r="0" g="0" b="0"/>
-          </a:lnRef>
-          <a:fillRef idx="0">
-            <a:scrgbClr r="0" g="0" b="0"/>
-          </a:fillRef>
-          <a:effectRef idx="0">
-            <a:scrgbClr r="0" g="0" b="0"/>
-          </a:effectRef>
-          <a:fontRef idx="minor">
-            <a:schemeClr val="dk1"/>
-          </a:fontRef>
-        </p:style>
-        <p:txBody>
-          <a:bodyPr wrap="square" lIns="0" tIns="0" rIns="0" bIns="0" rtlCol="0" anchor="t"/>
-          <a:lstStyle>
-            <a:lvl1pPr marL="0" indent="0">
-              <a:defRPr sz="1100">
-                <a:solidFill>
-                  <a:schemeClr val="dk1"/>
-                </a:solidFill>
-                <a:latin typeface="+mn-lt"/>
-                <a:ea typeface="+mn-ea"/>
-                <a:cs typeface="+mn-cs"/>
-              </a:defRPr>
-            </a:lvl1pPr>
-            <a:lvl2pPr marL="457200" indent="0">
-              <a:defRPr sz="1100">
-                <a:solidFill>
-                  <a:schemeClr val="dk1"/>
-                </a:solidFill>
-                <a:latin typeface="+mn-lt"/>
-                <a:ea typeface="+mn-ea"/>
-                <a:cs typeface="+mn-cs"/>
-              </a:defRPr>
-            </a:lvl2pPr>
-            <a:lvl3pPr marL="914400" indent="0">
-              <a:defRPr sz="1100">
-                <a:solidFill>
-                  <a:schemeClr val="dk1"/>
-                </a:solidFill>
-                <a:latin typeface="+mn-lt"/>
-                <a:ea typeface="+mn-ea"/>
-                <a:cs typeface="+mn-cs"/>
-              </a:defRPr>
-            </a:lvl3pPr>
-            <a:lvl4pPr marL="1371600" indent="0">
-              <a:defRPr sz="1100">
-                <a:solidFill>
-                  <a:schemeClr val="dk1"/>
-                </a:solidFill>
-                <a:latin typeface="+mn-lt"/>
-                <a:ea typeface="+mn-ea"/>
-                <a:cs typeface="+mn-cs"/>
-              </a:defRPr>
-            </a:lvl4pPr>
-            <a:lvl5pPr marL="1828800" indent="0">
-              <a:defRPr sz="1100">
-                <a:solidFill>
-                  <a:schemeClr val="dk1"/>
-                </a:solidFill>
-                <a:latin typeface="+mn-lt"/>
-                <a:ea typeface="+mn-ea"/>
-                <a:cs typeface="+mn-cs"/>
-              </a:defRPr>
-            </a:lvl5pPr>
-            <a:lvl6pPr marL="2286000" indent="0">
-              <a:defRPr sz="1100">
-                <a:solidFill>
-                  <a:schemeClr val="dk1"/>
-                </a:solidFill>
-                <a:latin typeface="+mn-lt"/>
-                <a:ea typeface="+mn-ea"/>
-                <a:cs typeface="+mn-cs"/>
-              </a:defRPr>
-            </a:lvl6pPr>
-            <a:lvl7pPr marL="2743200" indent="0">
-              <a:defRPr sz="1100">
-                <a:solidFill>
-                  <a:schemeClr val="dk1"/>
-                </a:solidFill>
-                <a:latin typeface="+mn-lt"/>
-                <a:ea typeface="+mn-ea"/>
-                <a:cs typeface="+mn-cs"/>
-              </a:defRPr>
-            </a:lvl7pPr>
-            <a:lvl8pPr marL="3200400" indent="0">
-              <a:defRPr sz="1100">
-                <a:solidFill>
-                  <a:schemeClr val="dk1"/>
-                </a:solidFill>
-                <a:latin typeface="+mn-lt"/>
-                <a:ea typeface="+mn-ea"/>
-                <a:cs typeface="+mn-cs"/>
-              </a:defRPr>
-            </a:lvl8pPr>
-            <a:lvl9pPr marL="3657600" indent="0">
-              <a:defRPr sz="1100">
-                <a:solidFill>
-                  <a:schemeClr val="dk1"/>
-                </a:solidFill>
-                <a:latin typeface="+mn-lt"/>
-                <a:ea typeface="+mn-ea"/>
-                <a:cs typeface="+mn-cs"/>
-              </a:defRPr>
-            </a:lvl9pPr>
-          </a:lstStyle>
-          <a:p>
-            <a:r>
-              <a:rPr lang="en-US" sz="800" b="1" dirty="0">
-                <a:latin typeface="Arial Narrow" panose="020B0606020202030204" pitchFamily="34" charset="0"/>
-                <a:cs typeface="Arial" panose="020B0604020202020204" pitchFamily="34" charset="0"/>
-              </a:rPr>
-              <a:t>{</a:t>
-            </a:r>
-            <a:r>
-              <a:rPr lang="en-US" sz="800" b="1" dirty="0" err="1">
-                <a:latin typeface="Arial Narrow" panose="020B0606020202030204" pitchFamily="34" charset="0"/>
-                <a:cs typeface="Arial" panose="020B0604020202020204" pitchFamily="34" charset="0"/>
-              </a:rPr>
-              <a:t>PresentAddress</a:t>
-            </a:r>
-            <a:r>
-              <a:rPr lang="en-US" sz="800" b="1" dirty="0">
-                <a:latin typeface="Arial Narrow" panose="020B0606020202030204" pitchFamily="34" charset="0"/>
-                <a:cs typeface="Arial" panose="020B0604020202020204" pitchFamily="34" charset="0"/>
-              </a:rPr>
-              <a:t>}</a:t>
-            </a:r>
-          </a:p>
-        </p:txBody>
-      </p:sp>
-      <p:sp>
-        <p:nvSpPr>
-          <p:cNvPr id="28" name="Name">
-            <a:extLst>
-              <a:ext uri="{FF2B5EF4-FFF2-40B4-BE49-F238E27FC236}">
-                <a16:creationId xmlns:a16="http://schemas.microsoft.com/office/drawing/2014/main" id="{52CFE58F-A7EA-4BA3-9851-E20D1B246B99}"/>
-              </a:ext>
-            </a:extLst>
-          </p:cNvPr>
-          <p:cNvSpPr txBox="1"/>
-          <p:nvPr/>
-        </p:nvSpPr>
-        <p:spPr>
-          <a:xfrm>
-            <a:off x="1113664" y="1977584"/>
-            <a:ext cx="772467" cy="156887"/>
-          </a:xfrm>
-          <a:prstGeom prst="rect">
-            <a:avLst/>
-          </a:prstGeom>
-          <a:solidFill>
-            <a:schemeClr val="bg1"/>
-          </a:solidFill>
-          <a:ln w="9525" cmpd="sng">
-            <a:noFill/>
-          </a:ln>
-        </p:spPr>
-        <p:style>
-          <a:lnRef idx="0">
-            <a:scrgbClr r="0" g="0" b="0"/>
-          </a:lnRef>
-          <a:fillRef idx="0">
-            <a:scrgbClr r="0" g="0" b="0"/>
-          </a:fillRef>
-          <a:effectRef idx="0">
-            <a:scrgbClr r="0" g="0" b="0"/>
-          </a:effectRef>
-          <a:fontRef idx="minor">
-            <a:schemeClr val="dk1"/>
-          </a:fontRef>
-        </p:style>
-        <p:txBody>
-          <a:bodyPr wrap="square" lIns="0" tIns="0" rIns="0" bIns="0" rtlCol="0" anchor="ctr"/>
-          <a:lstStyle>
-            <a:lvl1pPr marL="0" indent="0">
-              <a:defRPr sz="1100">
-                <a:solidFill>
-                  <a:schemeClr val="dk1"/>
-                </a:solidFill>
-                <a:latin typeface="+mn-lt"/>
-                <a:ea typeface="+mn-ea"/>
-                <a:cs typeface="+mn-cs"/>
-              </a:defRPr>
-            </a:lvl1pPr>
-            <a:lvl2pPr marL="457200" indent="0">
-              <a:defRPr sz="1100">
-                <a:solidFill>
-                  <a:schemeClr val="dk1"/>
-                </a:solidFill>
-                <a:latin typeface="+mn-lt"/>
-                <a:ea typeface="+mn-ea"/>
-                <a:cs typeface="+mn-cs"/>
-              </a:defRPr>
-            </a:lvl2pPr>
-            <a:lvl3pPr marL="914400" indent="0">
-              <a:defRPr sz="1100">
-                <a:solidFill>
-                  <a:schemeClr val="dk1"/>
-                </a:solidFill>
-                <a:latin typeface="+mn-lt"/>
-                <a:ea typeface="+mn-ea"/>
-                <a:cs typeface="+mn-cs"/>
-              </a:defRPr>
-            </a:lvl3pPr>
-            <a:lvl4pPr marL="1371600" indent="0">
-              <a:defRPr sz="1100">
-                <a:solidFill>
-                  <a:schemeClr val="dk1"/>
-                </a:solidFill>
-                <a:latin typeface="+mn-lt"/>
-                <a:ea typeface="+mn-ea"/>
-                <a:cs typeface="+mn-cs"/>
-              </a:defRPr>
-            </a:lvl4pPr>
-            <a:lvl5pPr marL="1828800" indent="0">
-              <a:defRPr sz="1100">
-                <a:solidFill>
-                  <a:schemeClr val="dk1"/>
-                </a:solidFill>
-                <a:latin typeface="+mn-lt"/>
-                <a:ea typeface="+mn-ea"/>
-                <a:cs typeface="+mn-cs"/>
-              </a:defRPr>
-            </a:lvl5pPr>
-            <a:lvl6pPr marL="2286000" indent="0">
-              <a:defRPr sz="1100">
-                <a:solidFill>
-                  <a:schemeClr val="dk1"/>
-                </a:solidFill>
-                <a:latin typeface="+mn-lt"/>
-                <a:ea typeface="+mn-ea"/>
-                <a:cs typeface="+mn-cs"/>
-              </a:defRPr>
-            </a:lvl6pPr>
-            <a:lvl7pPr marL="2743200" indent="0">
-              <a:defRPr sz="1100">
-                <a:solidFill>
-                  <a:schemeClr val="dk1"/>
-                </a:solidFill>
-                <a:latin typeface="+mn-lt"/>
-                <a:ea typeface="+mn-ea"/>
-                <a:cs typeface="+mn-cs"/>
-              </a:defRPr>
-            </a:lvl7pPr>
-            <a:lvl8pPr marL="3200400" indent="0">
-              <a:defRPr sz="1100">
-                <a:solidFill>
-                  <a:schemeClr val="dk1"/>
-                </a:solidFill>
-                <a:latin typeface="+mn-lt"/>
-                <a:ea typeface="+mn-ea"/>
-                <a:cs typeface="+mn-cs"/>
-              </a:defRPr>
-            </a:lvl8pPr>
-            <a:lvl9pPr marL="3657600" indent="0">
-              <a:defRPr sz="1100">
-                <a:solidFill>
-                  <a:schemeClr val="dk1"/>
-                </a:solidFill>
-                <a:latin typeface="+mn-lt"/>
-                <a:ea typeface="+mn-ea"/>
-                <a:cs typeface="+mn-cs"/>
-              </a:defRPr>
-            </a:lvl9pPr>
-          </a:lstStyle>
-          <a:p>
-            <a:r>
-              <a:rPr lang="en-US" sz="800" b="1" dirty="0">
-                <a:latin typeface="Arial Narrow" panose="020B0606020202030204" pitchFamily="34" charset="0"/>
-                <a:cs typeface="Arial" panose="020B0604020202020204" pitchFamily="34" charset="0"/>
-              </a:rPr>
-              <a:t>{</a:t>
-            </a:r>
-            <a:r>
-              <a:rPr lang="en-US" sz="800" b="1" dirty="0" err="1">
-                <a:latin typeface="Arial Narrow" panose="020B0606020202030204" pitchFamily="34" charset="0"/>
-                <a:cs typeface="Arial" panose="020B0604020202020204" pitchFamily="34" charset="0"/>
-              </a:rPr>
-              <a:t>EmergencyTelNo</a:t>
-            </a:r>
-            <a:r>
-              <a:rPr lang="en-US" sz="800" b="1" dirty="0">
-                <a:latin typeface="Arial Narrow" panose="020B0606020202030204" pitchFamily="34" charset="0"/>
-                <a:cs typeface="Arial" panose="020B0604020202020204" pitchFamily="34" charset="0"/>
-              </a:rPr>
-              <a:t>}</a:t>
-            </a:r>
-          </a:p>
-        </p:txBody>
-      </p:sp>
-      <p:sp>
-        <p:nvSpPr>
-          <p:cNvPr id="29" name="TextBox 28">
-            <a:extLst>
-              <a:ext uri="{FF2B5EF4-FFF2-40B4-BE49-F238E27FC236}">
-                <a16:creationId xmlns:a16="http://schemas.microsoft.com/office/drawing/2014/main" id="{6D610A8B-7CE8-4394-B052-B32EC31B152E}"/>
-              </a:ext>
-            </a:extLst>
-          </p:cNvPr>
-          <p:cNvSpPr txBox="1"/>
-          <p:nvPr/>
-        </p:nvSpPr>
-        <p:spPr>
-          <a:xfrm>
-            <a:off x="678519" y="1832703"/>
-            <a:ext cx="850583" cy="215444"/>
-          </a:xfrm>
-          <a:prstGeom prst="rect">
-            <a:avLst/>
-          </a:prstGeom>
-          <a:noFill/>
-        </p:spPr>
-        <p:txBody>
-          <a:bodyPr wrap="square">
-            <a:spAutoFit/>
-          </a:bodyPr>
-          <a:lstStyle/>
-          <a:p>
-            <a:r>
-              <a:rPr lang="en-US" sz="800" b="1" dirty="0">
-                <a:effectLst/>
-                <a:latin typeface="Arial Narrow" panose="020B0606020202030204" pitchFamily="34" charset="0"/>
-                <a:ea typeface="Times New Roman" panose="02020603050405020304" pitchFamily="18" charset="0"/>
-                <a:cs typeface="Calibri Light" panose="020F0302020204030204" pitchFamily="34" charset="0"/>
-              </a:rPr>
-              <a:t>{</a:t>
-            </a:r>
-            <a:r>
-              <a:rPr lang="en-US" sz="800" b="1" dirty="0" err="1">
-                <a:effectLst/>
-                <a:latin typeface="Arial Narrow" panose="020B0606020202030204" pitchFamily="34" charset="0"/>
-                <a:ea typeface="Times New Roman" panose="02020603050405020304" pitchFamily="18" charset="0"/>
-                <a:cs typeface="Calibri Light" panose="020F0302020204030204" pitchFamily="34" charset="0"/>
-              </a:rPr>
-              <a:t>FatherName</a:t>
-            </a:r>
-            <a:r>
-              <a:rPr lang="en-US" sz="800" b="1" dirty="0">
-                <a:effectLst/>
-                <a:latin typeface="Arial Narrow" panose="020B0606020202030204" pitchFamily="34" charset="0"/>
-                <a:ea typeface="Times New Roman" panose="02020603050405020304" pitchFamily="18" charset="0"/>
-                <a:cs typeface="Calibri Light" panose="020F0302020204030204" pitchFamily="34" charset="0"/>
-              </a:rPr>
-              <a:t>}</a:t>
-            </a:r>
-            <a:endParaRPr lang="en-US" sz="800" b="1" dirty="0">
-              <a:latin typeface="Arial Narrow" panose="020B0606020202030204" pitchFamily="34" charset="0"/>
-            </a:endParaRPr>
-          </a:p>
-        </p:txBody>
-      </p:sp>
-      <p:sp>
-        <p:nvSpPr>
-          <p:cNvPr id="30" name="DOJ">
-            <a:extLst>
-              <a:ext uri="{FF2B5EF4-FFF2-40B4-BE49-F238E27FC236}">
-                <a16:creationId xmlns:a16="http://schemas.microsoft.com/office/drawing/2014/main" id="{7579A1B9-655D-4F5D-A4FA-5AE8EC09CB1B}"/>
-              </a:ext>
-            </a:extLst>
-          </p:cNvPr>
-          <p:cNvSpPr txBox="1"/>
-          <p:nvPr/>
-        </p:nvSpPr>
-        <p:spPr>
-          <a:xfrm>
-            <a:off x="774873" y="1518688"/>
-            <a:ext cx="1054646" cy="120281"/>
-          </a:xfrm>
-          <a:prstGeom prst="rect">
-            <a:avLst/>
-          </a:prstGeom>
-          <a:noFill/>
-          <a:ln w="9525" cmpd="sng">
-            <a:noFill/>
-          </a:ln>
-        </p:spPr>
-        <p:style>
-          <a:lnRef idx="0">
-            <a:scrgbClr r="0" g="0" b="0"/>
-          </a:lnRef>
-          <a:fillRef idx="0">
-            <a:scrgbClr r="0" g="0" b="0"/>
-          </a:fillRef>
-          <a:effectRef idx="0">
-            <a:scrgbClr r="0" g="0" b="0"/>
-          </a:effectRef>
-          <a:fontRef idx="minor">
-            <a:schemeClr val="dk1"/>
-          </a:fontRef>
-        </p:style>
-        <p:txBody>
-          <a:bodyPr wrap="square" lIns="0" tIns="0" rIns="0" bIns="0" rtlCol="0" anchor="ctr"/>
-          <a:lstStyle>
-            <a:lvl1pPr marL="0" indent="0">
-              <a:defRPr sz="1100">
-                <a:solidFill>
-                  <a:schemeClr val="dk1"/>
-                </a:solidFill>
-                <a:latin typeface="+mn-lt"/>
-                <a:ea typeface="+mn-ea"/>
-                <a:cs typeface="+mn-cs"/>
-              </a:defRPr>
-            </a:lvl1pPr>
-            <a:lvl2pPr marL="457200" indent="0">
-              <a:defRPr sz="1100">
-                <a:solidFill>
-                  <a:schemeClr val="dk1"/>
-                </a:solidFill>
-                <a:latin typeface="+mn-lt"/>
-                <a:ea typeface="+mn-ea"/>
-                <a:cs typeface="+mn-cs"/>
-              </a:defRPr>
-            </a:lvl2pPr>
-            <a:lvl3pPr marL="914400" indent="0">
-              <a:defRPr sz="1100">
-                <a:solidFill>
-                  <a:schemeClr val="dk1"/>
-                </a:solidFill>
-                <a:latin typeface="+mn-lt"/>
-                <a:ea typeface="+mn-ea"/>
-                <a:cs typeface="+mn-cs"/>
-              </a:defRPr>
-            </a:lvl3pPr>
-            <a:lvl4pPr marL="1371600" indent="0">
-              <a:defRPr sz="1100">
-                <a:solidFill>
-                  <a:schemeClr val="dk1"/>
-                </a:solidFill>
-                <a:latin typeface="+mn-lt"/>
-                <a:ea typeface="+mn-ea"/>
-                <a:cs typeface="+mn-cs"/>
-              </a:defRPr>
-            </a:lvl4pPr>
-            <a:lvl5pPr marL="1828800" indent="0">
-              <a:defRPr sz="1100">
-                <a:solidFill>
-                  <a:schemeClr val="dk1"/>
-                </a:solidFill>
-                <a:latin typeface="+mn-lt"/>
-                <a:ea typeface="+mn-ea"/>
-                <a:cs typeface="+mn-cs"/>
-              </a:defRPr>
-            </a:lvl5pPr>
-            <a:lvl6pPr marL="2286000" indent="0">
-              <a:defRPr sz="1100">
-                <a:solidFill>
-                  <a:schemeClr val="dk1"/>
-                </a:solidFill>
-                <a:latin typeface="+mn-lt"/>
-                <a:ea typeface="+mn-ea"/>
-                <a:cs typeface="+mn-cs"/>
-              </a:defRPr>
-            </a:lvl6pPr>
-            <a:lvl7pPr marL="2743200" indent="0">
-              <a:defRPr sz="1100">
-                <a:solidFill>
-                  <a:schemeClr val="dk1"/>
-                </a:solidFill>
-                <a:latin typeface="+mn-lt"/>
-                <a:ea typeface="+mn-ea"/>
-                <a:cs typeface="+mn-cs"/>
-              </a:defRPr>
-            </a:lvl7pPr>
-            <a:lvl8pPr marL="3200400" indent="0">
-              <a:defRPr sz="1100">
-                <a:solidFill>
-                  <a:schemeClr val="dk1"/>
-                </a:solidFill>
-                <a:latin typeface="+mn-lt"/>
-                <a:ea typeface="+mn-ea"/>
-                <a:cs typeface="+mn-cs"/>
-              </a:defRPr>
-            </a:lvl8pPr>
-            <a:lvl9pPr marL="3657600" indent="0">
-              <a:defRPr sz="1100">
-                <a:solidFill>
-                  <a:schemeClr val="dk1"/>
-                </a:solidFill>
-                <a:latin typeface="+mn-lt"/>
-                <a:ea typeface="+mn-ea"/>
-                <a:cs typeface="+mn-cs"/>
-              </a:defRPr>
-            </a:lvl9pPr>
-          </a:lstStyle>
-          <a:p>
-            <a:r>
-              <a:rPr lang="en-US" sz="800" b="1" dirty="0">
-                <a:latin typeface="Arial Narrow" panose="020B0606020202030204" pitchFamily="34" charset="0"/>
-                <a:cs typeface="Arial" panose="020B0604020202020204" pitchFamily="34" charset="0"/>
-              </a:rPr>
-              <a:t>{Plant}</a:t>
-            </a:r>
-          </a:p>
-        </p:txBody>
-      </p:sp>
-      <p:sp>
-        <p:nvSpPr>
-          <p:cNvPr id="23" name="TextBox 22">
-            <a:extLst>
-              <a:ext uri="{FF2B5EF4-FFF2-40B4-BE49-F238E27FC236}">
-                <a16:creationId xmlns:a16="http://schemas.microsoft.com/office/drawing/2014/main" id="{BD1706BE-F5A5-4206-99CD-82FB8BEFA565}"/>
-              </a:ext>
-            </a:extLst>
-          </p:cNvPr>
-          <p:cNvSpPr txBox="1"/>
-          <p:nvPr/>
-        </p:nvSpPr>
-        <p:spPr>
-          <a:xfrm>
-            <a:off x="38986" y="2604893"/>
-            <a:ext cx="1872714" cy="415498"/>
-          </a:xfrm>
-          <a:prstGeom prst="rect">
-            <a:avLst/>
-          </a:prstGeom>
-          <a:solidFill>
-            <a:srgbClr val="FF9933"/>
-          </a:solidFill>
-        </p:spPr>
-        <p:txBody>
-          <a:bodyPr wrap="square">
-            <a:spAutoFit/>
-          </a:bodyPr>
-          <a:lstStyle/>
-          <a:p>
-            <a:pPr algn="ctr"/>
-            <a:r>
-              <a:rPr lang="hi-IN" sz="700" dirty="0"/>
-              <a:t>प्लॉट नंबर:4</a:t>
-            </a:r>
-            <a:r>
-              <a:rPr lang="en-US" sz="700" dirty="0"/>
-              <a:t>, </a:t>
-            </a:r>
-            <a:r>
-              <a:rPr lang="hi-IN" sz="700" dirty="0"/>
-              <a:t>औद्योगिक विकास केन्द्र</a:t>
-            </a:r>
-            <a:r>
-              <a:rPr lang="en-US" sz="700" dirty="0"/>
-              <a:t> </a:t>
-            </a:r>
-            <a:r>
-              <a:rPr lang="hi-IN" sz="700" dirty="0"/>
-              <a:t>खेड़ा,</a:t>
-            </a:r>
-            <a:r>
-              <a:rPr lang="en-US" sz="700" dirty="0"/>
-              <a:t> </a:t>
-            </a:r>
-            <a:r>
-              <a:rPr lang="hi-IN" sz="700" dirty="0"/>
-              <a:t>पीथमपुर जिला।</a:t>
-            </a:r>
-            <a:r>
-              <a:rPr lang="en-US" sz="700" dirty="0"/>
-              <a:t> </a:t>
-            </a:r>
-            <a:r>
-              <a:rPr lang="hi-IN" sz="700" dirty="0"/>
-              <a:t>धार, मध्य प्रदेश पिन</a:t>
-            </a:r>
-            <a:r>
-              <a:rPr lang="en-US" sz="700" dirty="0"/>
-              <a:t> </a:t>
-            </a:r>
-            <a:r>
-              <a:rPr lang="hi-IN" sz="700" dirty="0"/>
-              <a:t>454774</a:t>
-            </a:r>
-            <a:endParaRPr lang="en-US" sz="700" dirty="0"/>
-          </a:p>
-          <a:p>
-            <a:pPr algn="ctr"/>
-            <a:r>
-              <a:rPr lang="hi-IN" sz="700" dirty="0">
-                <a:latin typeface="Arial" panose="020B0604020202020204" pitchFamily="34" charset="0"/>
-                <a:ea typeface="Arial" panose="020B0604020202020204" pitchFamily="34" charset="0"/>
-              </a:rPr>
-              <a:t>फ़ोन </a:t>
-            </a:r>
-            <a:r>
-              <a:rPr lang="en-US" sz="700" dirty="0">
-                <a:latin typeface="Arial" panose="020B0604020202020204" pitchFamily="34" charset="0"/>
-                <a:ea typeface="Arial" panose="020B0604020202020204" pitchFamily="34" charset="0"/>
-              </a:rPr>
-              <a:t>0</a:t>
-            </a:r>
-            <a:r>
-              <a:rPr lang="en-US" sz="700" dirty="0">
-                <a:effectLst/>
-                <a:latin typeface="Arial" panose="020B0604020202020204" pitchFamily="34" charset="0"/>
-                <a:ea typeface="Arial" panose="020B0604020202020204" pitchFamily="34" charset="0"/>
-              </a:rPr>
-              <a:t>7292 404362/63</a:t>
-            </a:r>
-            <a:endParaRPr lang="en-US" sz="700" dirty="0"/>
-          </a:p>
-        </p:txBody>
-      </p:sp>
-      <p:pic>
-        <p:nvPicPr>
-          <p:cNvPr id="31" name="EmpQR">
-            <a:extLst>
-              <a:ext uri="{FF2B5EF4-FFF2-40B4-BE49-F238E27FC236}">
-                <a16:creationId xmlns:a16="http://schemas.microsoft.com/office/drawing/2014/main" id="{DC0F8D45-F3F9-48FC-8FBB-C5A99414D13C}"/>
+                <a16:creationId xmlns:a16="http://schemas.microsoft.com/office/drawing/2014/main" id="{12099DF0-B6C7-4212-A593-0E928E1475C4}"/>
               </a:ext>
             </a:extLst>
           </p:cNvPr>
@@ -6250,20 +4954,799 @@
         </p:blipFill>
         <p:spPr>
           <a:xfrm>
-            <a:off x="1178596" y="575188"/>
-            <a:ext cx="531267" cy="468701"/>
+            <a:off x="1136469" y="2633441"/>
+            <a:ext cx="594472" cy="273136"/>
           </a:xfrm>
           <a:prstGeom prst="rect">
             <a:avLst/>
           </a:prstGeom>
         </p:spPr>
       </p:pic>
+    </p:spTree>
+    <p:extLst>
+      <p:ext uri="{BB962C8B-B14F-4D97-AF65-F5344CB8AC3E}">
+        <p14:creationId xmlns:p14="http://schemas.microsoft.com/office/powerpoint/2010/main" val="3596783069"/>
+      </p:ext>
+    </p:extLst>
+  </p:cSld>
+  <p:clrMapOvr>
+    <a:masterClrMapping/>
+  </p:clrMapOvr>
+</p:sld>
+</file>
+
+<file path=ppt/slides/slide2.xml><?xml version="1.0" encoding="utf-8"?>
+<p:sld xmlns:a="http://schemas.openxmlformats.org/drawingml/2006/main" xmlns:r="http://schemas.openxmlformats.org/officeDocument/2006/relationships" xmlns:p="http://schemas.openxmlformats.org/presentationml/2006/main">
+  <p:cSld>
+    <p:spTree>
+      <p:nvGrpSpPr>
+        <p:cNvPr id="1" name=""/>
+        <p:cNvGrpSpPr/>
+        <p:nvPr/>
+      </p:nvGrpSpPr>
+      <p:grpSpPr>
+        <a:xfrm>
+          <a:off x="0" y="0"/>
+          <a:ext cx="0" cy="0"/>
+          <a:chOff x="0" y="0"/>
+          <a:chExt cx="0" cy="0"/>
+        </a:xfrm>
+      </p:grpSpPr>
+      <p:sp>
+        <p:nvSpPr>
+          <p:cNvPr id="2" name="Rectangle 1">
+            <a:extLst>
+              <a:ext uri="{FF2B5EF4-FFF2-40B4-BE49-F238E27FC236}">
+                <a16:creationId xmlns:a16="http://schemas.microsoft.com/office/drawing/2014/main" id="{C7D1C8D5-29BB-4F01-B4AC-1EBC0A312B5F}"/>
+              </a:ext>
+            </a:extLst>
+          </p:cNvPr>
+          <p:cNvSpPr/>
+          <p:nvPr/>
+        </p:nvSpPr>
+        <p:spPr>
+          <a:xfrm>
+            <a:off x="85196" y="33868"/>
+            <a:ext cx="1777471" cy="2980266"/>
+          </a:xfrm>
+          <a:prstGeom prst="rect">
+            <a:avLst/>
+          </a:prstGeom>
+          <a:noFill/>
+          <a:ln>
+            <a:solidFill>
+              <a:schemeClr val="tx1"/>
+            </a:solidFill>
+          </a:ln>
+        </p:spPr>
+        <p:style>
+          <a:lnRef idx="2">
+            <a:schemeClr val="accent1">
+              <a:shade val="50000"/>
+            </a:schemeClr>
+          </a:lnRef>
+          <a:fillRef idx="1">
+            <a:schemeClr val="accent1"/>
+          </a:fillRef>
+          <a:effectRef idx="0">
+            <a:schemeClr val="accent1"/>
+          </a:effectRef>
+          <a:fontRef idx="minor">
+            <a:schemeClr val="lt1"/>
+          </a:fontRef>
+        </p:style>
+        <p:txBody>
+          <a:bodyPr rtlCol="0" anchor="ctr"/>
+          <a:lstStyle/>
+          <a:p>
+            <a:pPr algn="ctr"/>
+            <a:endParaRPr lang="en-US" sz="600" dirty="0"/>
+          </a:p>
+        </p:txBody>
+      </p:sp>
+      <p:sp>
+        <p:nvSpPr>
+          <p:cNvPr id="5" name="TextBox 4">
+            <a:extLst>
+              <a:ext uri="{FF2B5EF4-FFF2-40B4-BE49-F238E27FC236}">
+                <a16:creationId xmlns:a16="http://schemas.microsoft.com/office/drawing/2014/main" id="{86D279EC-1DC9-466D-BDCB-63E10F4AEAD5}"/>
+              </a:ext>
+            </a:extLst>
+          </p:cNvPr>
+          <p:cNvSpPr txBox="1"/>
+          <p:nvPr/>
+        </p:nvSpPr>
+        <p:spPr>
+          <a:xfrm>
+            <a:off x="85195" y="2483213"/>
+            <a:ext cx="1777471" cy="492443"/>
+          </a:xfrm>
+          <a:prstGeom prst="rect">
+            <a:avLst/>
+          </a:prstGeom>
+          <a:noFill/>
+        </p:spPr>
+        <p:txBody>
+          <a:bodyPr wrap="square">
+            <a:spAutoFit/>
+          </a:bodyPr>
+          <a:lstStyle/>
+          <a:p>
+            <a:r>
+              <a:rPr lang="hi-IN" sz="800" b="1" dirty="0"/>
+              <a:t>प्रतिभा सिंटेक्स लिमिटेड</a:t>
+            </a:r>
+            <a:endParaRPr lang="en-US" sz="800" b="1" dirty="0"/>
+          </a:p>
+          <a:p>
+            <a:r>
+              <a:rPr lang="hi-IN" sz="600" dirty="0"/>
+              <a:t>प्लॉट नंबर:4</a:t>
+            </a:r>
+            <a:r>
+              <a:rPr lang="en-US" sz="600" dirty="0"/>
+              <a:t>, </a:t>
+            </a:r>
+            <a:r>
+              <a:rPr lang="hi-IN" sz="600" dirty="0"/>
+              <a:t>औद्योगिक विकास केन्द्र</a:t>
+            </a:r>
+            <a:r>
+              <a:rPr lang="en-US" sz="600" dirty="0"/>
+              <a:t> </a:t>
+            </a:r>
+            <a:r>
+              <a:rPr lang="hi-IN" sz="600" dirty="0"/>
+              <a:t>खेड़ा, पीथमपुर जिला। धार, मध्य प्रदेश पिन 454774</a:t>
+            </a:r>
+            <a:endParaRPr lang="en-US" sz="600" dirty="0"/>
+          </a:p>
+          <a:p>
+            <a:r>
+              <a:rPr lang="hi-IN" sz="600" dirty="0">
+                <a:latin typeface="Arial" panose="020B0604020202020204" pitchFamily="34" charset="0"/>
+                <a:ea typeface="Arial" panose="020B0604020202020204" pitchFamily="34" charset="0"/>
+              </a:rPr>
+              <a:t>फ़ोन </a:t>
+            </a:r>
+            <a:r>
+              <a:rPr lang="en-US" sz="600" dirty="0">
+                <a:latin typeface="Arial" panose="020B0604020202020204" pitchFamily="34" charset="0"/>
+                <a:ea typeface="Arial" panose="020B0604020202020204" pitchFamily="34" charset="0"/>
+              </a:rPr>
+              <a:t>0</a:t>
+            </a:r>
+            <a:r>
+              <a:rPr lang="en-US" sz="600" dirty="0">
+                <a:effectLst/>
+                <a:latin typeface="Arial" panose="020B0604020202020204" pitchFamily="34" charset="0"/>
+                <a:ea typeface="Arial" panose="020B0604020202020204" pitchFamily="34" charset="0"/>
+              </a:rPr>
+              <a:t>7292 404362/63</a:t>
+            </a:r>
+            <a:endParaRPr lang="en-US" sz="600" dirty="0"/>
+          </a:p>
+        </p:txBody>
+      </p:sp>
+      <p:sp>
+        <p:nvSpPr>
+          <p:cNvPr id="8" name="TextBox 7">
+            <a:extLst>
+              <a:ext uri="{FF2B5EF4-FFF2-40B4-BE49-F238E27FC236}">
+                <a16:creationId xmlns:a16="http://schemas.microsoft.com/office/drawing/2014/main" id="{BC858EA0-335F-4987-9961-49526D32D3E0}"/>
+              </a:ext>
+            </a:extLst>
+          </p:cNvPr>
+          <p:cNvSpPr txBox="1"/>
+          <p:nvPr/>
+        </p:nvSpPr>
+        <p:spPr>
+          <a:xfrm>
+            <a:off x="65602" y="1137356"/>
+            <a:ext cx="1005554" cy="1140697"/>
+          </a:xfrm>
+          <a:prstGeom prst="rect">
+            <a:avLst/>
+          </a:prstGeom>
+          <a:noFill/>
+        </p:spPr>
+        <p:txBody>
+          <a:bodyPr wrap="square">
+            <a:spAutoFit/>
+          </a:bodyPr>
+          <a:lstStyle/>
+          <a:p>
+            <a:pPr>
+              <a:lnSpc>
+                <a:spcPct val="150000"/>
+              </a:lnSpc>
+            </a:pPr>
+            <a:r>
+              <a:rPr lang="hi-IN" sz="700" dirty="0"/>
+              <a:t>पिता/पति का नाम</a:t>
+            </a:r>
+            <a:r>
+              <a:rPr lang="en-US" sz="700" dirty="0"/>
+              <a:t>:</a:t>
+            </a:r>
+          </a:p>
+          <a:p>
+            <a:pPr>
+              <a:lnSpc>
+                <a:spcPct val="150000"/>
+              </a:lnSpc>
+            </a:pPr>
+            <a:endParaRPr lang="en-US" sz="400" dirty="0"/>
+          </a:p>
+          <a:p>
+            <a:pPr>
+              <a:lnSpc>
+                <a:spcPct val="150000"/>
+              </a:lnSpc>
+            </a:pPr>
+            <a:r>
+              <a:rPr lang="hi-IN" sz="700" dirty="0"/>
+              <a:t>आपातकालीन फोन नंबर</a:t>
+            </a:r>
+            <a:r>
+              <a:rPr lang="en-US" sz="700" dirty="0"/>
+              <a:t>		:</a:t>
+            </a:r>
+            <a:endParaRPr lang="hi-IN" sz="700" dirty="0"/>
+          </a:p>
+          <a:p>
+            <a:pPr>
+              <a:lnSpc>
+                <a:spcPct val="150000"/>
+              </a:lnSpc>
+            </a:pPr>
+            <a:r>
+              <a:rPr lang="hi-IN" sz="700" dirty="0"/>
+              <a:t>जन्मदिन</a:t>
+            </a:r>
+            <a:r>
+              <a:rPr lang="en-US" sz="700" dirty="0"/>
+              <a:t>	:</a:t>
+            </a:r>
+            <a:endParaRPr lang="hi-IN" sz="700" dirty="0"/>
+          </a:p>
+          <a:p>
+            <a:pPr>
+              <a:lnSpc>
+                <a:spcPct val="150000"/>
+              </a:lnSpc>
+            </a:pPr>
+            <a:r>
+              <a:rPr lang="hi-IN" sz="700" dirty="0"/>
+              <a:t>रक्त समूह</a:t>
+            </a:r>
+            <a:r>
+              <a:rPr lang="en-US" sz="700" dirty="0"/>
+              <a:t>	:</a:t>
+            </a:r>
+            <a:endParaRPr lang="hi-IN" sz="700" dirty="0"/>
+          </a:p>
+          <a:p>
+            <a:pPr>
+              <a:lnSpc>
+                <a:spcPct val="150000"/>
+              </a:lnSpc>
+            </a:pPr>
+            <a:r>
+              <a:rPr lang="hi-IN" sz="700" dirty="0"/>
+              <a:t>पता</a:t>
+            </a:r>
+            <a:r>
+              <a:rPr lang="en-US" sz="700" dirty="0"/>
+              <a:t>: </a:t>
+            </a:r>
+            <a:endParaRPr lang="hi-IN" sz="700" dirty="0"/>
+          </a:p>
+        </p:txBody>
+      </p:sp>
+      <p:sp>
+        <p:nvSpPr>
+          <p:cNvPr id="11" name="BloodGroup">
+            <a:extLst>
+              <a:ext uri="{FF2B5EF4-FFF2-40B4-BE49-F238E27FC236}">
+                <a16:creationId xmlns:a16="http://schemas.microsoft.com/office/drawing/2014/main" id="{D4D882E2-EDEE-45D0-8519-E46F41CB214B}"/>
+              </a:ext>
+            </a:extLst>
+          </p:cNvPr>
+          <p:cNvSpPr txBox="1"/>
+          <p:nvPr/>
+        </p:nvSpPr>
+        <p:spPr>
+          <a:xfrm>
+            <a:off x="568819" y="1947530"/>
+            <a:ext cx="955106" cy="128342"/>
+          </a:xfrm>
+          <a:prstGeom prst="rect">
+            <a:avLst/>
+          </a:prstGeom>
+          <a:noFill/>
+          <a:ln w="9525" cmpd="sng">
+            <a:noFill/>
+          </a:ln>
+        </p:spPr>
+        <p:style>
+          <a:lnRef idx="0">
+            <a:scrgbClr r="0" g="0" b="0"/>
+          </a:lnRef>
+          <a:fillRef idx="0">
+            <a:scrgbClr r="0" g="0" b="0"/>
+          </a:fillRef>
+          <a:effectRef idx="0">
+            <a:scrgbClr r="0" g="0" b="0"/>
+          </a:effectRef>
+          <a:fontRef idx="minor">
+            <a:schemeClr val="dk1"/>
+          </a:fontRef>
+        </p:style>
+        <p:txBody>
+          <a:bodyPr wrap="square" lIns="0" tIns="0" rIns="0" bIns="0" rtlCol="0" anchor="ctr"/>
+          <a:lstStyle>
+            <a:lvl1pPr marL="0" indent="0">
+              <a:defRPr sz="1100">
+                <a:solidFill>
+                  <a:schemeClr val="dk1"/>
+                </a:solidFill>
+                <a:latin typeface="+mn-lt"/>
+                <a:ea typeface="+mn-ea"/>
+                <a:cs typeface="+mn-cs"/>
+              </a:defRPr>
+            </a:lvl1pPr>
+            <a:lvl2pPr marL="457200" indent="0">
+              <a:defRPr sz="1100">
+                <a:solidFill>
+                  <a:schemeClr val="dk1"/>
+                </a:solidFill>
+                <a:latin typeface="+mn-lt"/>
+                <a:ea typeface="+mn-ea"/>
+                <a:cs typeface="+mn-cs"/>
+              </a:defRPr>
+            </a:lvl2pPr>
+            <a:lvl3pPr marL="914400" indent="0">
+              <a:defRPr sz="1100">
+                <a:solidFill>
+                  <a:schemeClr val="dk1"/>
+                </a:solidFill>
+                <a:latin typeface="+mn-lt"/>
+                <a:ea typeface="+mn-ea"/>
+                <a:cs typeface="+mn-cs"/>
+              </a:defRPr>
+            </a:lvl3pPr>
+            <a:lvl4pPr marL="1371600" indent="0">
+              <a:defRPr sz="1100">
+                <a:solidFill>
+                  <a:schemeClr val="dk1"/>
+                </a:solidFill>
+                <a:latin typeface="+mn-lt"/>
+                <a:ea typeface="+mn-ea"/>
+                <a:cs typeface="+mn-cs"/>
+              </a:defRPr>
+            </a:lvl4pPr>
+            <a:lvl5pPr marL="1828800" indent="0">
+              <a:defRPr sz="1100">
+                <a:solidFill>
+                  <a:schemeClr val="dk1"/>
+                </a:solidFill>
+                <a:latin typeface="+mn-lt"/>
+                <a:ea typeface="+mn-ea"/>
+                <a:cs typeface="+mn-cs"/>
+              </a:defRPr>
+            </a:lvl5pPr>
+            <a:lvl6pPr marL="2286000" indent="0">
+              <a:defRPr sz="1100">
+                <a:solidFill>
+                  <a:schemeClr val="dk1"/>
+                </a:solidFill>
+                <a:latin typeface="+mn-lt"/>
+                <a:ea typeface="+mn-ea"/>
+                <a:cs typeface="+mn-cs"/>
+              </a:defRPr>
+            </a:lvl6pPr>
+            <a:lvl7pPr marL="2743200" indent="0">
+              <a:defRPr sz="1100">
+                <a:solidFill>
+                  <a:schemeClr val="dk1"/>
+                </a:solidFill>
+                <a:latin typeface="+mn-lt"/>
+                <a:ea typeface="+mn-ea"/>
+                <a:cs typeface="+mn-cs"/>
+              </a:defRPr>
+            </a:lvl7pPr>
+            <a:lvl8pPr marL="3200400" indent="0">
+              <a:defRPr sz="1100">
+                <a:solidFill>
+                  <a:schemeClr val="dk1"/>
+                </a:solidFill>
+                <a:latin typeface="+mn-lt"/>
+                <a:ea typeface="+mn-ea"/>
+                <a:cs typeface="+mn-cs"/>
+              </a:defRPr>
+            </a:lvl8pPr>
+            <a:lvl9pPr marL="3657600" indent="0">
+              <a:defRPr sz="1100">
+                <a:solidFill>
+                  <a:schemeClr val="dk1"/>
+                </a:solidFill>
+                <a:latin typeface="+mn-lt"/>
+                <a:ea typeface="+mn-ea"/>
+                <a:cs typeface="+mn-cs"/>
+              </a:defRPr>
+            </a:lvl9pPr>
+          </a:lstStyle>
+          <a:p>
+            <a:r>
+              <a:rPr lang="en-US" sz="600" b="1" dirty="0">
+                <a:latin typeface="Arial Narrow" panose="020B0606020202030204" pitchFamily="34" charset="0"/>
+                <a:cs typeface="Aharoni" panose="02010803020104030203" pitchFamily="2" charset="-79"/>
+              </a:rPr>
+              <a:t>{BloodGroup}</a:t>
+            </a:r>
+          </a:p>
+        </p:txBody>
+      </p:sp>
+      <p:sp>
+        <p:nvSpPr>
+          <p:cNvPr id="12" name="DOJ">
+            <a:extLst>
+              <a:ext uri="{FF2B5EF4-FFF2-40B4-BE49-F238E27FC236}">
+                <a16:creationId xmlns:a16="http://schemas.microsoft.com/office/drawing/2014/main" id="{19A6A632-0E1E-4A29-88A8-4814D728EAA6}"/>
+              </a:ext>
+            </a:extLst>
+          </p:cNvPr>
+          <p:cNvSpPr txBox="1"/>
+          <p:nvPr/>
+        </p:nvSpPr>
+        <p:spPr>
+          <a:xfrm>
+            <a:off x="580571" y="1786388"/>
+            <a:ext cx="942017" cy="117276"/>
+          </a:xfrm>
+          <a:prstGeom prst="rect">
+            <a:avLst/>
+          </a:prstGeom>
+          <a:noFill/>
+          <a:ln w="9525" cmpd="sng">
+            <a:noFill/>
+          </a:ln>
+        </p:spPr>
+        <p:style>
+          <a:lnRef idx="0">
+            <a:scrgbClr r="0" g="0" b="0"/>
+          </a:lnRef>
+          <a:fillRef idx="0">
+            <a:scrgbClr r="0" g="0" b="0"/>
+          </a:fillRef>
+          <a:effectRef idx="0">
+            <a:scrgbClr r="0" g="0" b="0"/>
+          </a:effectRef>
+          <a:fontRef idx="minor">
+            <a:schemeClr val="dk1"/>
+          </a:fontRef>
+        </p:style>
+        <p:txBody>
+          <a:bodyPr wrap="square" lIns="0" tIns="0" rIns="0" bIns="0" rtlCol="0" anchor="ctr"/>
+          <a:lstStyle>
+            <a:lvl1pPr marL="0" indent="0">
+              <a:defRPr sz="1100">
+                <a:solidFill>
+                  <a:schemeClr val="dk1"/>
+                </a:solidFill>
+                <a:latin typeface="+mn-lt"/>
+                <a:ea typeface="+mn-ea"/>
+                <a:cs typeface="+mn-cs"/>
+              </a:defRPr>
+            </a:lvl1pPr>
+            <a:lvl2pPr marL="457200" indent="0">
+              <a:defRPr sz="1100">
+                <a:solidFill>
+                  <a:schemeClr val="dk1"/>
+                </a:solidFill>
+                <a:latin typeface="+mn-lt"/>
+                <a:ea typeface="+mn-ea"/>
+                <a:cs typeface="+mn-cs"/>
+              </a:defRPr>
+            </a:lvl2pPr>
+            <a:lvl3pPr marL="914400" indent="0">
+              <a:defRPr sz="1100">
+                <a:solidFill>
+                  <a:schemeClr val="dk1"/>
+                </a:solidFill>
+                <a:latin typeface="+mn-lt"/>
+                <a:ea typeface="+mn-ea"/>
+                <a:cs typeface="+mn-cs"/>
+              </a:defRPr>
+            </a:lvl3pPr>
+            <a:lvl4pPr marL="1371600" indent="0">
+              <a:defRPr sz="1100">
+                <a:solidFill>
+                  <a:schemeClr val="dk1"/>
+                </a:solidFill>
+                <a:latin typeface="+mn-lt"/>
+                <a:ea typeface="+mn-ea"/>
+                <a:cs typeface="+mn-cs"/>
+              </a:defRPr>
+            </a:lvl4pPr>
+            <a:lvl5pPr marL="1828800" indent="0">
+              <a:defRPr sz="1100">
+                <a:solidFill>
+                  <a:schemeClr val="dk1"/>
+                </a:solidFill>
+                <a:latin typeface="+mn-lt"/>
+                <a:ea typeface="+mn-ea"/>
+                <a:cs typeface="+mn-cs"/>
+              </a:defRPr>
+            </a:lvl5pPr>
+            <a:lvl6pPr marL="2286000" indent="0">
+              <a:defRPr sz="1100">
+                <a:solidFill>
+                  <a:schemeClr val="dk1"/>
+                </a:solidFill>
+                <a:latin typeface="+mn-lt"/>
+                <a:ea typeface="+mn-ea"/>
+                <a:cs typeface="+mn-cs"/>
+              </a:defRPr>
+            </a:lvl6pPr>
+            <a:lvl7pPr marL="2743200" indent="0">
+              <a:defRPr sz="1100">
+                <a:solidFill>
+                  <a:schemeClr val="dk1"/>
+                </a:solidFill>
+                <a:latin typeface="+mn-lt"/>
+                <a:ea typeface="+mn-ea"/>
+                <a:cs typeface="+mn-cs"/>
+              </a:defRPr>
+            </a:lvl7pPr>
+            <a:lvl8pPr marL="3200400" indent="0">
+              <a:defRPr sz="1100">
+                <a:solidFill>
+                  <a:schemeClr val="dk1"/>
+                </a:solidFill>
+                <a:latin typeface="+mn-lt"/>
+                <a:ea typeface="+mn-ea"/>
+                <a:cs typeface="+mn-cs"/>
+              </a:defRPr>
+            </a:lvl8pPr>
+            <a:lvl9pPr marL="3657600" indent="0">
+              <a:defRPr sz="1100">
+                <a:solidFill>
+                  <a:schemeClr val="dk1"/>
+                </a:solidFill>
+                <a:latin typeface="+mn-lt"/>
+                <a:ea typeface="+mn-ea"/>
+                <a:cs typeface="+mn-cs"/>
+              </a:defRPr>
+            </a:lvl9pPr>
+          </a:lstStyle>
+          <a:p>
+            <a:r>
+              <a:rPr lang="en-US" sz="600" b="1" dirty="0">
+                <a:latin typeface="Arial Narrow" panose="020B0606020202030204" pitchFamily="34" charset="0"/>
+                <a:cs typeface="Aharoni" panose="02010803020104030203" pitchFamily="2" charset="-79"/>
+              </a:rPr>
+              <a:t>{DOJ}</a:t>
+            </a:r>
+          </a:p>
+        </p:txBody>
+      </p:sp>
+      <p:sp>
+        <p:nvSpPr>
+          <p:cNvPr id="14" name="PermanentAddress">
+            <a:extLst>
+              <a:ext uri="{FF2B5EF4-FFF2-40B4-BE49-F238E27FC236}">
+                <a16:creationId xmlns:a16="http://schemas.microsoft.com/office/drawing/2014/main" id="{1BBB861F-2C7F-4276-9326-2D2263A36EDC}"/>
+              </a:ext>
+            </a:extLst>
+          </p:cNvPr>
+          <p:cNvSpPr txBox="1"/>
+          <p:nvPr/>
+        </p:nvSpPr>
+        <p:spPr>
+          <a:xfrm>
+            <a:off x="388494" y="2101996"/>
+            <a:ext cx="1313078" cy="332824"/>
+          </a:xfrm>
+          <a:prstGeom prst="rect">
+            <a:avLst/>
+          </a:prstGeom>
+          <a:solidFill>
+            <a:schemeClr val="lt1"/>
+          </a:solidFill>
+          <a:ln w="9525" cmpd="sng">
+            <a:noFill/>
+          </a:ln>
+        </p:spPr>
+        <p:style>
+          <a:lnRef idx="0">
+            <a:scrgbClr r="0" g="0" b="0"/>
+          </a:lnRef>
+          <a:fillRef idx="0">
+            <a:scrgbClr r="0" g="0" b="0"/>
+          </a:fillRef>
+          <a:effectRef idx="0">
+            <a:scrgbClr r="0" g="0" b="0"/>
+          </a:effectRef>
+          <a:fontRef idx="minor">
+            <a:schemeClr val="dk1"/>
+          </a:fontRef>
+        </p:style>
+        <p:txBody>
+          <a:bodyPr wrap="square" lIns="0" tIns="0" rIns="0" bIns="0" rtlCol="0" anchor="t"/>
+          <a:lstStyle>
+            <a:lvl1pPr marL="0" indent="0">
+              <a:defRPr sz="1100">
+                <a:solidFill>
+                  <a:schemeClr val="dk1"/>
+                </a:solidFill>
+                <a:latin typeface="+mn-lt"/>
+                <a:ea typeface="+mn-ea"/>
+                <a:cs typeface="+mn-cs"/>
+              </a:defRPr>
+            </a:lvl1pPr>
+            <a:lvl2pPr marL="457200" indent="0">
+              <a:defRPr sz="1100">
+                <a:solidFill>
+                  <a:schemeClr val="dk1"/>
+                </a:solidFill>
+                <a:latin typeface="+mn-lt"/>
+                <a:ea typeface="+mn-ea"/>
+                <a:cs typeface="+mn-cs"/>
+              </a:defRPr>
+            </a:lvl2pPr>
+            <a:lvl3pPr marL="914400" indent="0">
+              <a:defRPr sz="1100">
+                <a:solidFill>
+                  <a:schemeClr val="dk1"/>
+                </a:solidFill>
+                <a:latin typeface="+mn-lt"/>
+                <a:ea typeface="+mn-ea"/>
+                <a:cs typeface="+mn-cs"/>
+              </a:defRPr>
+            </a:lvl3pPr>
+            <a:lvl4pPr marL="1371600" indent="0">
+              <a:defRPr sz="1100">
+                <a:solidFill>
+                  <a:schemeClr val="dk1"/>
+                </a:solidFill>
+                <a:latin typeface="+mn-lt"/>
+                <a:ea typeface="+mn-ea"/>
+                <a:cs typeface="+mn-cs"/>
+              </a:defRPr>
+            </a:lvl4pPr>
+            <a:lvl5pPr marL="1828800" indent="0">
+              <a:defRPr sz="1100">
+                <a:solidFill>
+                  <a:schemeClr val="dk1"/>
+                </a:solidFill>
+                <a:latin typeface="+mn-lt"/>
+                <a:ea typeface="+mn-ea"/>
+                <a:cs typeface="+mn-cs"/>
+              </a:defRPr>
+            </a:lvl5pPr>
+            <a:lvl6pPr marL="2286000" indent="0">
+              <a:defRPr sz="1100">
+                <a:solidFill>
+                  <a:schemeClr val="dk1"/>
+                </a:solidFill>
+                <a:latin typeface="+mn-lt"/>
+                <a:ea typeface="+mn-ea"/>
+                <a:cs typeface="+mn-cs"/>
+              </a:defRPr>
+            </a:lvl6pPr>
+            <a:lvl7pPr marL="2743200" indent="0">
+              <a:defRPr sz="1100">
+                <a:solidFill>
+                  <a:schemeClr val="dk1"/>
+                </a:solidFill>
+                <a:latin typeface="+mn-lt"/>
+                <a:ea typeface="+mn-ea"/>
+                <a:cs typeface="+mn-cs"/>
+              </a:defRPr>
+            </a:lvl7pPr>
+            <a:lvl8pPr marL="3200400" indent="0">
+              <a:defRPr sz="1100">
+                <a:solidFill>
+                  <a:schemeClr val="dk1"/>
+                </a:solidFill>
+                <a:latin typeface="+mn-lt"/>
+                <a:ea typeface="+mn-ea"/>
+                <a:cs typeface="+mn-cs"/>
+              </a:defRPr>
+            </a:lvl8pPr>
+            <a:lvl9pPr marL="3657600" indent="0">
+              <a:defRPr sz="1100">
+                <a:solidFill>
+                  <a:schemeClr val="dk1"/>
+                </a:solidFill>
+                <a:latin typeface="+mn-lt"/>
+                <a:ea typeface="+mn-ea"/>
+                <a:cs typeface="+mn-cs"/>
+              </a:defRPr>
+            </a:lvl9pPr>
+          </a:lstStyle>
+          <a:p>
+            <a:r>
+              <a:rPr lang="en-US" sz="700" b="1" dirty="0">
+                <a:latin typeface="Arial Narrow" panose="020B0606020202030204" pitchFamily="34" charset="0"/>
+                <a:cs typeface="Arial" panose="020B0604020202020204" pitchFamily="34" charset="0"/>
+              </a:rPr>
+              <a:t>{</a:t>
+            </a:r>
+            <a:r>
+              <a:rPr lang="en-US" sz="700" b="1" dirty="0" err="1">
+                <a:latin typeface="Arial Narrow" panose="020B0606020202030204" pitchFamily="34" charset="0"/>
+                <a:cs typeface="Arial" panose="020B0604020202020204" pitchFamily="34" charset="0"/>
+              </a:rPr>
+              <a:t>PresentAddress</a:t>
+            </a:r>
+            <a:r>
+              <a:rPr lang="en-US" sz="700" b="1" dirty="0">
+                <a:latin typeface="Arial Narrow" panose="020B0606020202030204" pitchFamily="34" charset="0"/>
+                <a:cs typeface="Arial" panose="020B0604020202020204" pitchFamily="34" charset="0"/>
+              </a:rPr>
+              <a:t>}</a:t>
+            </a:r>
+          </a:p>
+          <a:p>
+            <a:endParaRPr lang="en-US" sz="700" b="1" dirty="0">
+              <a:latin typeface="Arial Narrow" panose="020B0606020202030204" pitchFamily="34" charset="0"/>
+              <a:cs typeface="Arial" panose="020B0604020202020204" pitchFamily="34" charset="0"/>
+            </a:endParaRPr>
+          </a:p>
+        </p:txBody>
+      </p:sp>
+      <p:sp>
+        <p:nvSpPr>
+          <p:cNvPr id="16" name="TextBox 15">
+            <a:extLst>
+              <a:ext uri="{FF2B5EF4-FFF2-40B4-BE49-F238E27FC236}">
+                <a16:creationId xmlns:a16="http://schemas.microsoft.com/office/drawing/2014/main" id="{C815F522-053A-4C77-8964-28D6B02E1DF1}"/>
+              </a:ext>
+            </a:extLst>
+          </p:cNvPr>
+          <p:cNvSpPr txBox="1"/>
+          <p:nvPr/>
+        </p:nvSpPr>
+        <p:spPr>
+          <a:xfrm>
+            <a:off x="823376" y="1161482"/>
+            <a:ext cx="973182" cy="200055"/>
+          </a:xfrm>
+          <a:prstGeom prst="rect">
+            <a:avLst/>
+          </a:prstGeom>
+          <a:noFill/>
+        </p:spPr>
+        <p:txBody>
+          <a:bodyPr wrap="square">
+            <a:spAutoFit/>
+          </a:bodyPr>
+          <a:lstStyle/>
+          <a:p>
+            <a:r>
+              <a:rPr lang="en-US" sz="700" dirty="0"/>
+              <a:t>{</a:t>
+            </a:r>
+            <a:r>
+              <a:rPr lang="en-US" sz="700" dirty="0" err="1"/>
+              <a:t>FatherOrSpouse</a:t>
+            </a:r>
+            <a:r>
+              <a:rPr lang="en-US" sz="700" dirty="0"/>
+              <a:t>}</a:t>
+            </a:r>
+          </a:p>
+        </p:txBody>
+      </p:sp>
       <p:pic>
         <p:nvPicPr>
-          <p:cNvPr id="32" name="AuthorizedSign">
+          <p:cNvPr id="3" name="Picture 2">
             <a:extLst>
               <a:ext uri="{FF2B5EF4-FFF2-40B4-BE49-F238E27FC236}">
-                <a16:creationId xmlns:a16="http://schemas.microsoft.com/office/drawing/2014/main" id="{12099DF0-B6C7-4212-A593-0E928E1475C4}"/>
+                <a16:creationId xmlns:a16="http://schemas.microsoft.com/office/drawing/2014/main" id="{2344378E-E334-4BBD-BA37-0DD60AD236B8}"/>
               </a:ext>
             </a:extLst>
           </p:cNvPr>
@@ -6273,27 +5756,182 @@
           <p:nvPr/>
         </p:nvPicPr>
         <p:blipFill>
-          <a:blip r:embed="rId5"/>
+          <a:blip r:embed="rId2"/>
           <a:stretch>
             <a:fillRect/>
           </a:stretch>
         </p:blipFill>
         <p:spPr>
           <a:xfrm>
-            <a:off x="1196539" y="2306496"/>
-            <a:ext cx="594472" cy="189812"/>
+            <a:off x="530013" y="227331"/>
+            <a:ext cx="786452" cy="792549"/>
           </a:xfrm>
           <a:prstGeom prst="rect">
             <a:avLst/>
           </a:prstGeom>
         </p:spPr>
       </p:pic>
+      <p:sp>
+        <p:nvSpPr>
+          <p:cNvPr id="15" name="Name">
+            <a:extLst>
+              <a:ext uri="{FF2B5EF4-FFF2-40B4-BE49-F238E27FC236}">
+                <a16:creationId xmlns:a16="http://schemas.microsoft.com/office/drawing/2014/main" id="{C65870EF-3CEF-4FF5-9295-F71C4976C006}"/>
+              </a:ext>
+            </a:extLst>
+          </p:cNvPr>
+          <p:cNvSpPr txBox="1"/>
+          <p:nvPr/>
+        </p:nvSpPr>
+        <p:spPr>
+          <a:xfrm>
+            <a:off x="562655" y="1592103"/>
+            <a:ext cx="845078" cy="156887"/>
+          </a:xfrm>
+          <a:prstGeom prst="rect">
+            <a:avLst/>
+          </a:prstGeom>
+          <a:solidFill>
+            <a:schemeClr val="bg1"/>
+          </a:solidFill>
+          <a:ln w="9525" cmpd="sng">
+            <a:noFill/>
+          </a:ln>
+        </p:spPr>
+        <p:style>
+          <a:lnRef idx="0">
+            <a:scrgbClr r="0" g="0" b="0"/>
+          </a:lnRef>
+          <a:fillRef idx="0">
+            <a:scrgbClr r="0" g="0" b="0"/>
+          </a:fillRef>
+          <a:effectRef idx="0">
+            <a:scrgbClr r="0" g="0" b="0"/>
+          </a:effectRef>
+          <a:fontRef idx="minor">
+            <a:schemeClr val="dk1"/>
+          </a:fontRef>
+        </p:style>
+        <p:txBody>
+          <a:bodyPr wrap="square" lIns="0" tIns="0" rIns="0" bIns="0" rtlCol="0" anchor="ctr"/>
+          <a:lstStyle>
+            <a:lvl1pPr marL="0" indent="0">
+              <a:defRPr sz="1100">
+                <a:solidFill>
+                  <a:schemeClr val="dk1"/>
+                </a:solidFill>
+                <a:latin typeface="+mn-lt"/>
+                <a:ea typeface="+mn-ea"/>
+                <a:cs typeface="+mn-cs"/>
+              </a:defRPr>
+            </a:lvl1pPr>
+            <a:lvl2pPr marL="457200" indent="0">
+              <a:defRPr sz="1100">
+                <a:solidFill>
+                  <a:schemeClr val="dk1"/>
+                </a:solidFill>
+                <a:latin typeface="+mn-lt"/>
+                <a:ea typeface="+mn-ea"/>
+                <a:cs typeface="+mn-cs"/>
+              </a:defRPr>
+            </a:lvl2pPr>
+            <a:lvl3pPr marL="914400" indent="0">
+              <a:defRPr sz="1100">
+                <a:solidFill>
+                  <a:schemeClr val="dk1"/>
+                </a:solidFill>
+                <a:latin typeface="+mn-lt"/>
+                <a:ea typeface="+mn-ea"/>
+                <a:cs typeface="+mn-cs"/>
+              </a:defRPr>
+            </a:lvl3pPr>
+            <a:lvl4pPr marL="1371600" indent="0">
+              <a:defRPr sz="1100">
+                <a:solidFill>
+                  <a:schemeClr val="dk1"/>
+                </a:solidFill>
+                <a:latin typeface="+mn-lt"/>
+                <a:ea typeface="+mn-ea"/>
+                <a:cs typeface="+mn-cs"/>
+              </a:defRPr>
+            </a:lvl4pPr>
+            <a:lvl5pPr marL="1828800" indent="0">
+              <a:defRPr sz="1100">
+                <a:solidFill>
+                  <a:schemeClr val="dk1"/>
+                </a:solidFill>
+                <a:latin typeface="+mn-lt"/>
+                <a:ea typeface="+mn-ea"/>
+                <a:cs typeface="+mn-cs"/>
+              </a:defRPr>
+            </a:lvl5pPr>
+            <a:lvl6pPr marL="2286000" indent="0">
+              <a:defRPr sz="1100">
+                <a:solidFill>
+                  <a:schemeClr val="dk1"/>
+                </a:solidFill>
+                <a:latin typeface="+mn-lt"/>
+                <a:ea typeface="+mn-ea"/>
+                <a:cs typeface="+mn-cs"/>
+              </a:defRPr>
+            </a:lvl6pPr>
+            <a:lvl7pPr marL="2743200" indent="0">
+              <a:defRPr sz="1100">
+                <a:solidFill>
+                  <a:schemeClr val="dk1"/>
+                </a:solidFill>
+                <a:latin typeface="+mn-lt"/>
+                <a:ea typeface="+mn-ea"/>
+                <a:cs typeface="+mn-cs"/>
+              </a:defRPr>
+            </a:lvl7pPr>
+            <a:lvl8pPr marL="3200400" indent="0">
+              <a:defRPr sz="1100">
+                <a:solidFill>
+                  <a:schemeClr val="dk1"/>
+                </a:solidFill>
+                <a:latin typeface="+mn-lt"/>
+                <a:ea typeface="+mn-ea"/>
+                <a:cs typeface="+mn-cs"/>
+              </a:defRPr>
+            </a:lvl8pPr>
+            <a:lvl9pPr marL="3657600" indent="0">
+              <a:defRPr sz="1100">
+                <a:solidFill>
+                  <a:schemeClr val="dk1"/>
+                </a:solidFill>
+                <a:latin typeface="+mn-lt"/>
+                <a:ea typeface="+mn-ea"/>
+                <a:cs typeface="+mn-cs"/>
+              </a:defRPr>
+            </a:lvl9pPr>
+          </a:lstStyle>
+          <a:p>
+            <a:r>
+              <a:rPr lang="en-US" sz="800" b="1" dirty="0">
+                <a:latin typeface="Arial Narrow" panose="020B0606020202030204" pitchFamily="34" charset="0"/>
+                <a:cs typeface="Arial" panose="020B0604020202020204" pitchFamily="34" charset="0"/>
+              </a:rPr>
+              <a:t>{</a:t>
+            </a:r>
+            <a:r>
+              <a:rPr lang="en-US" sz="800" dirty="0" err="1">
+                <a:latin typeface="Arial Narrow" panose="020B0606020202030204" pitchFamily="34" charset="0"/>
+                <a:cs typeface="Arial" panose="020B0604020202020204" pitchFamily="34" charset="0"/>
+              </a:rPr>
+              <a:t>EmergencyTelNo</a:t>
+            </a:r>
+            <a:r>
+              <a:rPr lang="en-US" sz="800" b="1" dirty="0">
+                <a:latin typeface="Arial Narrow" panose="020B0606020202030204" pitchFamily="34" charset="0"/>
+                <a:cs typeface="Arial" panose="020B0604020202020204" pitchFamily="34" charset="0"/>
+              </a:rPr>
+              <a:t>}</a:t>
+            </a:r>
+          </a:p>
+        </p:txBody>
+      </p:sp>
     </p:spTree>
-    <p:extLst>
-      <p:ext uri="{BB962C8B-B14F-4D97-AF65-F5344CB8AC3E}">
-        <p14:creationId xmlns:p14="http://schemas.microsoft.com/office/powerpoint/2010/main" val="3596783069"/>
-      </p:ext>
-    </p:extLst>
   </p:cSld>
   <p:clrMapOvr>
     <a:masterClrMapping/>

</xml_diff>